<commit_message>
Remove alternative trajectories models
</commit_message>
<xml_diff>
--- a/img/models.pptx
+++ b/img/models.pptx
@@ -2,18 +2,18 @@
 <file path=ppt/presentation.xml><?xml version="1.0" encoding="utf-8"?>
 <p:presentation xmlns:a="http://schemas.openxmlformats.org/drawingml/2006/main" xmlns:r="http://schemas.openxmlformats.org/officeDocument/2006/relationships" xmlns:p="http://schemas.openxmlformats.org/presentationml/2006/main" saveSubsetFonts="1" autoCompressPictures="0">
   <p:sldMasterIdLst>
-    <p:sldMasterId id="2147483648" r:id="rId1"/>
+    <p:sldMasterId id="2147483672" r:id="rId1"/>
   </p:sldMasterIdLst>
   <p:sldIdLst>
     <p:sldId id="256" r:id="rId2"/>
   </p:sldIdLst>
-  <p:sldSz cx="12192000" cy="6858000"/>
+  <p:sldSz cx="8999538" cy="5921375"/>
   <p:notesSz cx="6858000" cy="9144000"/>
   <p:defaultTextStyle>
     <a:defPPr>
       <a:defRPr lang="en-US"/>
     </a:defPPr>
-    <a:lvl1pPr marL="0" algn="l" defTabSz="914400" rtl="0" eaLnBrk="1" latinLnBrk="0" hangingPunct="1">
+    <a:lvl1pPr marL="0" algn="l" defTabSz="457200" rtl="0" eaLnBrk="1" latinLnBrk="0" hangingPunct="1">
       <a:defRPr sz="1800" kern="1200">
         <a:solidFill>
           <a:schemeClr val="tx1"/>
@@ -23,7 +23,7 @@
         <a:cs typeface="+mn-cs"/>
       </a:defRPr>
     </a:lvl1pPr>
-    <a:lvl2pPr marL="457200" algn="l" defTabSz="914400" rtl="0" eaLnBrk="1" latinLnBrk="0" hangingPunct="1">
+    <a:lvl2pPr marL="457200" algn="l" defTabSz="457200" rtl="0" eaLnBrk="1" latinLnBrk="0" hangingPunct="1">
       <a:defRPr sz="1800" kern="1200">
         <a:solidFill>
           <a:schemeClr val="tx1"/>
@@ -33,7 +33,7 @@
         <a:cs typeface="+mn-cs"/>
       </a:defRPr>
     </a:lvl2pPr>
-    <a:lvl3pPr marL="914400" algn="l" defTabSz="914400" rtl="0" eaLnBrk="1" latinLnBrk="0" hangingPunct="1">
+    <a:lvl3pPr marL="914400" algn="l" defTabSz="457200" rtl="0" eaLnBrk="1" latinLnBrk="0" hangingPunct="1">
       <a:defRPr sz="1800" kern="1200">
         <a:solidFill>
           <a:schemeClr val="tx1"/>
@@ -43,7 +43,7 @@
         <a:cs typeface="+mn-cs"/>
       </a:defRPr>
     </a:lvl3pPr>
-    <a:lvl4pPr marL="1371600" algn="l" defTabSz="914400" rtl="0" eaLnBrk="1" latinLnBrk="0" hangingPunct="1">
+    <a:lvl4pPr marL="1371600" algn="l" defTabSz="457200" rtl="0" eaLnBrk="1" latinLnBrk="0" hangingPunct="1">
       <a:defRPr sz="1800" kern="1200">
         <a:solidFill>
           <a:schemeClr val="tx1"/>
@@ -53,7 +53,7 @@
         <a:cs typeface="+mn-cs"/>
       </a:defRPr>
     </a:lvl4pPr>
-    <a:lvl5pPr marL="1828800" algn="l" defTabSz="914400" rtl="0" eaLnBrk="1" latinLnBrk="0" hangingPunct="1">
+    <a:lvl5pPr marL="1828800" algn="l" defTabSz="457200" rtl="0" eaLnBrk="1" latinLnBrk="0" hangingPunct="1">
       <a:defRPr sz="1800" kern="1200">
         <a:solidFill>
           <a:schemeClr val="tx1"/>
@@ -63,7 +63,7 @@
         <a:cs typeface="+mn-cs"/>
       </a:defRPr>
     </a:lvl5pPr>
-    <a:lvl6pPr marL="2286000" algn="l" defTabSz="914400" rtl="0" eaLnBrk="1" latinLnBrk="0" hangingPunct="1">
+    <a:lvl6pPr marL="2286000" algn="l" defTabSz="457200" rtl="0" eaLnBrk="1" latinLnBrk="0" hangingPunct="1">
       <a:defRPr sz="1800" kern="1200">
         <a:solidFill>
           <a:schemeClr val="tx1"/>
@@ -73,7 +73,7 @@
         <a:cs typeface="+mn-cs"/>
       </a:defRPr>
     </a:lvl6pPr>
-    <a:lvl7pPr marL="2743200" algn="l" defTabSz="914400" rtl="0" eaLnBrk="1" latinLnBrk="0" hangingPunct="1">
+    <a:lvl7pPr marL="2743200" algn="l" defTabSz="457200" rtl="0" eaLnBrk="1" latinLnBrk="0" hangingPunct="1">
       <a:defRPr sz="1800" kern="1200">
         <a:solidFill>
           <a:schemeClr val="tx1"/>
@@ -83,7 +83,7 @@
         <a:cs typeface="+mn-cs"/>
       </a:defRPr>
     </a:lvl7pPr>
-    <a:lvl8pPr marL="3200400" algn="l" defTabSz="914400" rtl="0" eaLnBrk="1" latinLnBrk="0" hangingPunct="1">
+    <a:lvl8pPr marL="3200400" algn="l" defTabSz="457200" rtl="0" eaLnBrk="1" latinLnBrk="0" hangingPunct="1">
       <a:defRPr sz="1800" kern="1200">
         <a:solidFill>
           <a:schemeClr val="tx1"/>
@@ -93,7 +93,7 @@
         <a:cs typeface="+mn-cs"/>
       </a:defRPr>
     </a:lvl8pPr>
-    <a:lvl9pPr marL="3657600" algn="l" defTabSz="914400" rtl="0" eaLnBrk="1" latinLnBrk="0" hangingPunct="1">
+    <a:lvl9pPr marL="3657600" algn="l" defTabSz="457200" rtl="0" eaLnBrk="1" latinLnBrk="0" hangingPunct="1">
       <a:defRPr sz="1800" kern="1200">
         <a:solidFill>
           <a:schemeClr val="tx1"/>
@@ -107,12 +107,12 @@
   <p:extLst>
     <p:ext uri="{EFAFB233-063F-42B5-8137-9DF3F51BA10A}">
       <p15:sldGuideLst xmlns:p15="http://schemas.microsoft.com/office/powerpoint/2012/main">
-        <p15:guide id="1" orient="horz" pos="2160" userDrawn="1">
+        <p15:guide id="1" orient="horz" pos="1865" userDrawn="1">
           <p15:clr>
             <a:srgbClr val="A4A3A4"/>
           </p15:clr>
         </p15:guide>
-        <p15:guide id="2" pos="3840" userDrawn="1">
+        <p15:guide id="2" pos="2835" userDrawn="1">
           <p15:clr>
             <a:srgbClr val="A4A3A4"/>
           </p15:clr>
@@ -142,13 +142,7 @@
       </p:grpSpPr>
       <p:sp>
         <p:nvSpPr>
-          <p:cNvPr id="2" name="Title 1">
-            <a:extLst>
-              <a:ext uri="{FF2B5EF4-FFF2-40B4-BE49-F238E27FC236}">
-                <a16:creationId xmlns:a16="http://schemas.microsoft.com/office/drawing/2014/main" id="{3D2DAB6F-1288-4B96-BCF8-64D1B1E537AE}"/>
-              </a:ext>
-            </a:extLst>
-          </p:cNvPr>
+          <p:cNvPr id="2" name="Title 1"/>
           <p:cNvSpPr>
             <a:spLocks noGrp="1"/>
           </p:cNvSpPr>
@@ -158,15 +152,15 @@
         </p:nvSpPr>
         <p:spPr>
           <a:xfrm>
-            <a:off x="1524000" y="1122363"/>
-            <a:ext cx="9144000" cy="2387600"/>
+            <a:off x="674966" y="969077"/>
+            <a:ext cx="7649607" cy="2061516"/>
           </a:xfrm>
         </p:spPr>
         <p:txBody>
           <a:bodyPr anchor="b"/>
           <a:lstStyle>
             <a:lvl1pPr algn="ctr">
-              <a:defRPr sz="6000"/>
+              <a:defRPr sz="5180"/>
             </a:lvl1pPr>
           </a:lstStyle>
           <a:p>
@@ -174,19 +168,13 @@
               <a:rPr lang="en-GB"/>
               <a:t>Click to edit Master title style</a:t>
             </a:r>
-            <a:endParaRPr lang="en-US"/>
-          </a:p>
-        </p:txBody>
-      </p:sp>
-      <p:sp>
-        <p:nvSpPr>
-          <p:cNvPr id="3" name="Subtitle 2">
-            <a:extLst>
-              <a:ext uri="{FF2B5EF4-FFF2-40B4-BE49-F238E27FC236}">
-                <a16:creationId xmlns:a16="http://schemas.microsoft.com/office/drawing/2014/main" id="{B5E82D4B-FFD3-4A6E-2D5D-0031DFD29818}"/>
-              </a:ext>
-            </a:extLst>
-          </p:cNvPr>
+            <a:endParaRPr lang="en-US" dirty="0"/>
+          </a:p>
+        </p:txBody>
+      </p:sp>
+      <p:sp>
+        <p:nvSpPr>
+          <p:cNvPr id="3" name="Subtitle 2"/>
           <p:cNvSpPr>
             <a:spLocks noGrp="1"/>
           </p:cNvSpPr>
@@ -196,8 +184,8 @@
         </p:nvSpPr>
         <p:spPr>
           <a:xfrm>
-            <a:off x="1524000" y="3602038"/>
-            <a:ext cx="9144000" cy="1655762"/>
+            <a:off x="1124942" y="3110093"/>
+            <a:ext cx="6749654" cy="1429628"/>
           </a:xfrm>
         </p:spPr>
         <p:txBody>
@@ -205,39 +193,39 @@
           <a:lstStyle>
             <a:lvl1pPr marL="0" indent="0" algn="ctr">
               <a:buNone/>
-              <a:defRPr sz="2400"/>
+              <a:defRPr sz="2072"/>
             </a:lvl1pPr>
-            <a:lvl2pPr marL="457200" indent="0" algn="ctr">
-              <a:buNone/>
-              <a:defRPr sz="2000"/>
+            <a:lvl2pPr marL="394746" indent="0" algn="ctr">
+              <a:buNone/>
+              <a:defRPr sz="1727"/>
             </a:lvl2pPr>
-            <a:lvl3pPr marL="914400" indent="0" algn="ctr">
-              <a:buNone/>
-              <a:defRPr sz="1800"/>
+            <a:lvl3pPr marL="789493" indent="0" algn="ctr">
+              <a:buNone/>
+              <a:defRPr sz="1554"/>
             </a:lvl3pPr>
-            <a:lvl4pPr marL="1371600" indent="0" algn="ctr">
-              <a:buNone/>
-              <a:defRPr sz="1600"/>
+            <a:lvl4pPr marL="1184239" indent="0" algn="ctr">
+              <a:buNone/>
+              <a:defRPr sz="1381"/>
             </a:lvl4pPr>
-            <a:lvl5pPr marL="1828800" indent="0" algn="ctr">
-              <a:buNone/>
-              <a:defRPr sz="1600"/>
+            <a:lvl5pPr marL="1578986" indent="0" algn="ctr">
+              <a:buNone/>
+              <a:defRPr sz="1381"/>
             </a:lvl5pPr>
-            <a:lvl6pPr marL="2286000" indent="0" algn="ctr">
-              <a:buNone/>
-              <a:defRPr sz="1600"/>
+            <a:lvl6pPr marL="1973732" indent="0" algn="ctr">
+              <a:buNone/>
+              <a:defRPr sz="1381"/>
             </a:lvl6pPr>
-            <a:lvl7pPr marL="2743200" indent="0" algn="ctr">
-              <a:buNone/>
-              <a:defRPr sz="1600"/>
+            <a:lvl7pPr marL="2368479" indent="0" algn="ctr">
+              <a:buNone/>
+              <a:defRPr sz="1381"/>
             </a:lvl7pPr>
-            <a:lvl8pPr marL="3200400" indent="0" algn="ctr">
-              <a:buNone/>
-              <a:defRPr sz="1600"/>
+            <a:lvl8pPr marL="2763225" indent="0" algn="ctr">
+              <a:buNone/>
+              <a:defRPr sz="1381"/>
             </a:lvl8pPr>
-            <a:lvl9pPr marL="3657600" indent="0" algn="ctr">
-              <a:buNone/>
-              <a:defRPr sz="1600"/>
+            <a:lvl9pPr marL="3157972" indent="0" algn="ctr">
+              <a:buNone/>
+              <a:defRPr sz="1381"/>
             </a:lvl9pPr>
           </a:lstStyle>
           <a:p>
@@ -245,19 +233,13 @@
               <a:rPr lang="en-GB"/>
               <a:t>Click to edit Master subtitle style</a:t>
             </a:r>
-            <a:endParaRPr lang="en-US"/>
-          </a:p>
-        </p:txBody>
-      </p:sp>
-      <p:sp>
-        <p:nvSpPr>
-          <p:cNvPr id="4" name="Date Placeholder 3">
-            <a:extLst>
-              <a:ext uri="{FF2B5EF4-FFF2-40B4-BE49-F238E27FC236}">
-                <a16:creationId xmlns:a16="http://schemas.microsoft.com/office/drawing/2014/main" id="{12A0AB26-F27C-B55C-495D-1F75BF70F35E}"/>
-              </a:ext>
-            </a:extLst>
-          </p:cNvPr>
+            <a:endParaRPr lang="en-US" dirty="0"/>
+          </a:p>
+        </p:txBody>
+      </p:sp>
+      <p:sp>
+        <p:nvSpPr>
+          <p:cNvPr id="4" name="Date Placeholder 3"/>
           <p:cNvSpPr>
             <a:spLocks noGrp="1"/>
           </p:cNvSpPr>
@@ -272,7 +254,7 @@
           <a:p>
             <a:fld id="{918BE157-C9BD-DB4B-B849-501D8C18A188}" type="datetimeFigureOut">
               <a:rPr lang="en-US" smtClean="0"/>
-              <a:t>6/2/26</a:t>
+              <a:t>9/9/26</a:t>
             </a:fld>
             <a:endParaRPr lang="en-US"/>
           </a:p>
@@ -280,13 +262,7 @@
       </p:sp>
       <p:sp>
         <p:nvSpPr>
-          <p:cNvPr id="5" name="Footer Placeholder 4">
-            <a:extLst>
-              <a:ext uri="{FF2B5EF4-FFF2-40B4-BE49-F238E27FC236}">
-                <a16:creationId xmlns:a16="http://schemas.microsoft.com/office/drawing/2014/main" id="{EE2BC7C2-C96A-AB11-2B29-8B56A2617A12}"/>
-              </a:ext>
-            </a:extLst>
-          </p:cNvPr>
+          <p:cNvPr id="5" name="Footer Placeholder 4"/>
           <p:cNvSpPr>
             <a:spLocks noGrp="1"/>
           </p:cNvSpPr>
@@ -305,13 +281,7 @@
       </p:sp>
       <p:sp>
         <p:nvSpPr>
-          <p:cNvPr id="6" name="Slide Number Placeholder 5">
-            <a:extLst>
-              <a:ext uri="{FF2B5EF4-FFF2-40B4-BE49-F238E27FC236}">
-                <a16:creationId xmlns:a16="http://schemas.microsoft.com/office/drawing/2014/main" id="{919D311B-D3E1-51F3-E8C1-AE4C982B80A3}"/>
-              </a:ext>
-            </a:extLst>
-          </p:cNvPr>
+          <p:cNvPr id="6" name="Slide Number Placeholder 5"/>
           <p:cNvSpPr>
             <a:spLocks noGrp="1"/>
           </p:cNvSpPr>
@@ -335,7 +305,7 @@
     </p:spTree>
     <p:extLst>
       <p:ext uri="{BB962C8B-B14F-4D97-AF65-F5344CB8AC3E}">
-        <p14:creationId xmlns:p14="http://schemas.microsoft.com/office/powerpoint/2010/main" val="817897427"/>
+        <p14:creationId xmlns:p14="http://schemas.microsoft.com/office/powerpoint/2010/main" val="687112224"/>
       </p:ext>
     </p:extLst>
   </p:cSld>
@@ -364,13 +334,7 @@
       </p:grpSpPr>
       <p:sp>
         <p:nvSpPr>
-          <p:cNvPr id="2" name="Title 1">
-            <a:extLst>
-              <a:ext uri="{FF2B5EF4-FFF2-40B4-BE49-F238E27FC236}">
-                <a16:creationId xmlns:a16="http://schemas.microsoft.com/office/drawing/2014/main" id="{E9913379-9091-3F25-765A-3C5CB7580264}"/>
-              </a:ext>
-            </a:extLst>
-          </p:cNvPr>
+          <p:cNvPr id="2" name="Title 1"/>
           <p:cNvSpPr>
             <a:spLocks noGrp="1"/>
           </p:cNvSpPr>
@@ -387,19 +351,13 @@
               <a:rPr lang="en-GB"/>
               <a:t>Click to edit Master title style</a:t>
             </a:r>
-            <a:endParaRPr lang="en-US"/>
-          </a:p>
-        </p:txBody>
-      </p:sp>
-      <p:sp>
-        <p:nvSpPr>
-          <p:cNvPr id="3" name="Vertical Text Placeholder 2">
-            <a:extLst>
-              <a:ext uri="{FF2B5EF4-FFF2-40B4-BE49-F238E27FC236}">
-                <a16:creationId xmlns:a16="http://schemas.microsoft.com/office/drawing/2014/main" id="{AF9157A7-6758-6474-1715-DF61D313BB9F}"/>
-              </a:ext>
-            </a:extLst>
-          </p:cNvPr>
+            <a:endParaRPr lang="en-US" dirty="0"/>
+          </a:p>
+        </p:txBody>
+      </p:sp>
+      <p:sp>
+        <p:nvSpPr>
+          <p:cNvPr id="3" name="Vertical Text Placeholder 2"/>
           <p:cNvSpPr>
             <a:spLocks noGrp="1"/>
           </p:cNvSpPr>
@@ -445,19 +403,13 @@
               <a:rPr lang="en-GB"/>
               <a:t>Fifth level</a:t>
             </a:r>
-            <a:endParaRPr lang="en-US"/>
-          </a:p>
-        </p:txBody>
-      </p:sp>
-      <p:sp>
-        <p:nvSpPr>
-          <p:cNvPr id="4" name="Date Placeholder 3">
-            <a:extLst>
-              <a:ext uri="{FF2B5EF4-FFF2-40B4-BE49-F238E27FC236}">
-                <a16:creationId xmlns:a16="http://schemas.microsoft.com/office/drawing/2014/main" id="{22F9B842-3BC4-7B31-C8BB-14D048CFFD47}"/>
-              </a:ext>
-            </a:extLst>
-          </p:cNvPr>
+            <a:endParaRPr lang="en-US" dirty="0"/>
+          </a:p>
+        </p:txBody>
+      </p:sp>
+      <p:sp>
+        <p:nvSpPr>
+          <p:cNvPr id="4" name="Date Placeholder 3"/>
           <p:cNvSpPr>
             <a:spLocks noGrp="1"/>
           </p:cNvSpPr>
@@ -472,7 +424,7 @@
           <a:p>
             <a:fld id="{918BE157-C9BD-DB4B-B849-501D8C18A188}" type="datetimeFigureOut">
               <a:rPr lang="en-US" smtClean="0"/>
-              <a:t>6/2/26</a:t>
+              <a:t>9/9/26</a:t>
             </a:fld>
             <a:endParaRPr lang="en-US"/>
           </a:p>
@@ -480,13 +432,7 @@
       </p:sp>
       <p:sp>
         <p:nvSpPr>
-          <p:cNvPr id="5" name="Footer Placeholder 4">
-            <a:extLst>
-              <a:ext uri="{FF2B5EF4-FFF2-40B4-BE49-F238E27FC236}">
-                <a16:creationId xmlns:a16="http://schemas.microsoft.com/office/drawing/2014/main" id="{1A646B2E-9912-13F1-4D69-181D5C07AD87}"/>
-              </a:ext>
-            </a:extLst>
-          </p:cNvPr>
+          <p:cNvPr id="5" name="Footer Placeholder 4"/>
           <p:cNvSpPr>
             <a:spLocks noGrp="1"/>
           </p:cNvSpPr>
@@ -505,13 +451,7 @@
       </p:sp>
       <p:sp>
         <p:nvSpPr>
-          <p:cNvPr id="6" name="Slide Number Placeholder 5">
-            <a:extLst>
-              <a:ext uri="{FF2B5EF4-FFF2-40B4-BE49-F238E27FC236}">
-                <a16:creationId xmlns:a16="http://schemas.microsoft.com/office/drawing/2014/main" id="{AAC3EF60-57E7-F7DE-8FA6-1D4F64ECB2CE}"/>
-              </a:ext>
-            </a:extLst>
-          </p:cNvPr>
+          <p:cNvPr id="6" name="Slide Number Placeholder 5"/>
           <p:cNvSpPr>
             <a:spLocks noGrp="1"/>
           </p:cNvSpPr>
@@ -535,7 +475,7 @@
     </p:spTree>
     <p:extLst>
       <p:ext uri="{BB962C8B-B14F-4D97-AF65-F5344CB8AC3E}">
-        <p14:creationId xmlns:p14="http://schemas.microsoft.com/office/powerpoint/2010/main" val="1377522075"/>
+        <p14:creationId xmlns:p14="http://schemas.microsoft.com/office/powerpoint/2010/main" val="14408952"/>
       </p:ext>
     </p:extLst>
   </p:cSld>
@@ -564,13 +504,7 @@
       </p:grpSpPr>
       <p:sp>
         <p:nvSpPr>
-          <p:cNvPr id="2" name="Vertical Title 1">
-            <a:extLst>
-              <a:ext uri="{FF2B5EF4-FFF2-40B4-BE49-F238E27FC236}">
-                <a16:creationId xmlns:a16="http://schemas.microsoft.com/office/drawing/2014/main" id="{85091619-59AC-B62A-AE95-A1D4D2E005B6}"/>
-              </a:ext>
-            </a:extLst>
-          </p:cNvPr>
+          <p:cNvPr id="2" name="Vertical Title 1"/>
           <p:cNvSpPr>
             <a:spLocks noGrp="1"/>
           </p:cNvSpPr>
@@ -580,8 +514,8 @@
         </p:nvSpPr>
         <p:spPr>
           <a:xfrm>
-            <a:off x="8724900" y="365125"/>
-            <a:ext cx="2628900" cy="5811838"/>
+            <a:off x="6440295" y="315258"/>
+            <a:ext cx="1940525" cy="5018092"/>
           </a:xfrm>
         </p:spPr>
         <p:txBody>
@@ -592,19 +526,13 @@
               <a:rPr lang="en-GB"/>
               <a:t>Click to edit Master title style</a:t>
             </a:r>
-            <a:endParaRPr lang="en-US"/>
-          </a:p>
-        </p:txBody>
-      </p:sp>
-      <p:sp>
-        <p:nvSpPr>
-          <p:cNvPr id="3" name="Vertical Text Placeholder 2">
-            <a:extLst>
-              <a:ext uri="{FF2B5EF4-FFF2-40B4-BE49-F238E27FC236}">
-                <a16:creationId xmlns:a16="http://schemas.microsoft.com/office/drawing/2014/main" id="{794B7FBE-96DC-2552-60C8-A3ACD35C745F}"/>
-              </a:ext>
-            </a:extLst>
-          </p:cNvPr>
+            <a:endParaRPr lang="en-US" dirty="0"/>
+          </a:p>
+        </p:txBody>
+      </p:sp>
+      <p:sp>
+        <p:nvSpPr>
+          <p:cNvPr id="3" name="Vertical Text Placeholder 2"/>
           <p:cNvSpPr>
             <a:spLocks noGrp="1"/>
           </p:cNvSpPr>
@@ -614,8 +542,8 @@
         </p:nvSpPr>
         <p:spPr>
           <a:xfrm>
-            <a:off x="838200" y="365125"/>
-            <a:ext cx="7734300" cy="5811838"/>
+            <a:off x="618719" y="315258"/>
+            <a:ext cx="5709082" cy="5018092"/>
           </a:xfrm>
         </p:spPr>
         <p:txBody>
@@ -655,19 +583,13 @@
               <a:rPr lang="en-GB"/>
               <a:t>Fifth level</a:t>
             </a:r>
-            <a:endParaRPr lang="en-US"/>
-          </a:p>
-        </p:txBody>
-      </p:sp>
-      <p:sp>
-        <p:nvSpPr>
-          <p:cNvPr id="4" name="Date Placeholder 3">
-            <a:extLst>
-              <a:ext uri="{FF2B5EF4-FFF2-40B4-BE49-F238E27FC236}">
-                <a16:creationId xmlns:a16="http://schemas.microsoft.com/office/drawing/2014/main" id="{7D8AF3F4-BB23-49D6-E327-5AE9A3ECC514}"/>
-              </a:ext>
-            </a:extLst>
-          </p:cNvPr>
+            <a:endParaRPr lang="en-US" dirty="0"/>
+          </a:p>
+        </p:txBody>
+      </p:sp>
+      <p:sp>
+        <p:nvSpPr>
+          <p:cNvPr id="4" name="Date Placeholder 3"/>
           <p:cNvSpPr>
             <a:spLocks noGrp="1"/>
           </p:cNvSpPr>
@@ -682,7 +604,7 @@
           <a:p>
             <a:fld id="{918BE157-C9BD-DB4B-B849-501D8C18A188}" type="datetimeFigureOut">
               <a:rPr lang="en-US" smtClean="0"/>
-              <a:t>6/2/26</a:t>
+              <a:t>9/9/26</a:t>
             </a:fld>
             <a:endParaRPr lang="en-US"/>
           </a:p>
@@ -690,13 +612,7 @@
       </p:sp>
       <p:sp>
         <p:nvSpPr>
-          <p:cNvPr id="5" name="Footer Placeholder 4">
-            <a:extLst>
-              <a:ext uri="{FF2B5EF4-FFF2-40B4-BE49-F238E27FC236}">
-                <a16:creationId xmlns:a16="http://schemas.microsoft.com/office/drawing/2014/main" id="{4CE1A638-C0AA-DED3-4F34-B0D1704C645C}"/>
-              </a:ext>
-            </a:extLst>
-          </p:cNvPr>
+          <p:cNvPr id="5" name="Footer Placeholder 4"/>
           <p:cNvSpPr>
             <a:spLocks noGrp="1"/>
           </p:cNvSpPr>
@@ -715,13 +631,7 @@
       </p:sp>
       <p:sp>
         <p:nvSpPr>
-          <p:cNvPr id="6" name="Slide Number Placeholder 5">
-            <a:extLst>
-              <a:ext uri="{FF2B5EF4-FFF2-40B4-BE49-F238E27FC236}">
-                <a16:creationId xmlns:a16="http://schemas.microsoft.com/office/drawing/2014/main" id="{2FA82A21-8403-E69A-4474-9ECD28A25C52}"/>
-              </a:ext>
-            </a:extLst>
-          </p:cNvPr>
+          <p:cNvPr id="6" name="Slide Number Placeholder 5"/>
           <p:cNvSpPr>
             <a:spLocks noGrp="1"/>
           </p:cNvSpPr>
@@ -745,7 +655,7 @@
     </p:spTree>
     <p:extLst>
       <p:ext uri="{BB962C8B-B14F-4D97-AF65-F5344CB8AC3E}">
-        <p14:creationId xmlns:p14="http://schemas.microsoft.com/office/powerpoint/2010/main" val="2800721095"/>
+        <p14:creationId xmlns:p14="http://schemas.microsoft.com/office/powerpoint/2010/main" val="400422245"/>
       </p:ext>
     </p:extLst>
   </p:cSld>
@@ -774,13 +684,7 @@
       </p:grpSpPr>
       <p:sp>
         <p:nvSpPr>
-          <p:cNvPr id="2" name="Title 1">
-            <a:extLst>
-              <a:ext uri="{FF2B5EF4-FFF2-40B4-BE49-F238E27FC236}">
-                <a16:creationId xmlns:a16="http://schemas.microsoft.com/office/drawing/2014/main" id="{AF771F2D-D4DE-462A-6988-B2DF0A3D65AA}"/>
-              </a:ext>
-            </a:extLst>
-          </p:cNvPr>
+          <p:cNvPr id="2" name="Title 1"/>
           <p:cNvSpPr>
             <a:spLocks noGrp="1"/>
           </p:cNvSpPr>
@@ -797,19 +701,13 @@
               <a:rPr lang="en-GB"/>
               <a:t>Click to edit Master title style</a:t>
             </a:r>
-            <a:endParaRPr lang="en-US"/>
-          </a:p>
-        </p:txBody>
-      </p:sp>
-      <p:sp>
-        <p:nvSpPr>
-          <p:cNvPr id="3" name="Content Placeholder 2">
-            <a:extLst>
-              <a:ext uri="{FF2B5EF4-FFF2-40B4-BE49-F238E27FC236}">
-                <a16:creationId xmlns:a16="http://schemas.microsoft.com/office/drawing/2014/main" id="{EE37298A-FC44-5891-FE54-A13BC1D3D494}"/>
-              </a:ext>
-            </a:extLst>
-          </p:cNvPr>
+            <a:endParaRPr lang="en-US" dirty="0"/>
+          </a:p>
+        </p:txBody>
+      </p:sp>
+      <p:sp>
+        <p:nvSpPr>
+          <p:cNvPr id="3" name="Content Placeholder 2"/>
           <p:cNvSpPr>
             <a:spLocks noGrp="1"/>
           </p:cNvSpPr>
@@ -855,19 +753,13 @@
               <a:rPr lang="en-GB"/>
               <a:t>Fifth level</a:t>
             </a:r>
-            <a:endParaRPr lang="en-US"/>
-          </a:p>
-        </p:txBody>
-      </p:sp>
-      <p:sp>
-        <p:nvSpPr>
-          <p:cNvPr id="4" name="Date Placeholder 3">
-            <a:extLst>
-              <a:ext uri="{FF2B5EF4-FFF2-40B4-BE49-F238E27FC236}">
-                <a16:creationId xmlns:a16="http://schemas.microsoft.com/office/drawing/2014/main" id="{EB147574-D703-F8F5-3587-C5D7EFA9922B}"/>
-              </a:ext>
-            </a:extLst>
-          </p:cNvPr>
+            <a:endParaRPr lang="en-US" dirty="0"/>
+          </a:p>
+        </p:txBody>
+      </p:sp>
+      <p:sp>
+        <p:nvSpPr>
+          <p:cNvPr id="4" name="Date Placeholder 3"/>
           <p:cNvSpPr>
             <a:spLocks noGrp="1"/>
           </p:cNvSpPr>
@@ -882,7 +774,7 @@
           <a:p>
             <a:fld id="{918BE157-C9BD-DB4B-B849-501D8C18A188}" type="datetimeFigureOut">
               <a:rPr lang="en-US" smtClean="0"/>
-              <a:t>6/2/26</a:t>
+              <a:t>9/9/26</a:t>
             </a:fld>
             <a:endParaRPr lang="en-US"/>
           </a:p>
@@ -890,13 +782,7 @@
       </p:sp>
       <p:sp>
         <p:nvSpPr>
-          <p:cNvPr id="5" name="Footer Placeholder 4">
-            <a:extLst>
-              <a:ext uri="{FF2B5EF4-FFF2-40B4-BE49-F238E27FC236}">
-                <a16:creationId xmlns:a16="http://schemas.microsoft.com/office/drawing/2014/main" id="{96706A10-77E1-DE9E-A775-D3C5AEBD015F}"/>
-              </a:ext>
-            </a:extLst>
-          </p:cNvPr>
+          <p:cNvPr id="5" name="Footer Placeholder 4"/>
           <p:cNvSpPr>
             <a:spLocks noGrp="1"/>
           </p:cNvSpPr>
@@ -915,13 +801,7 @@
       </p:sp>
       <p:sp>
         <p:nvSpPr>
-          <p:cNvPr id="6" name="Slide Number Placeholder 5">
-            <a:extLst>
-              <a:ext uri="{FF2B5EF4-FFF2-40B4-BE49-F238E27FC236}">
-                <a16:creationId xmlns:a16="http://schemas.microsoft.com/office/drawing/2014/main" id="{76FD0354-97F1-DDF5-4E90-F000D0EA7A77}"/>
-              </a:ext>
-            </a:extLst>
-          </p:cNvPr>
+          <p:cNvPr id="6" name="Slide Number Placeholder 5"/>
           <p:cNvSpPr>
             <a:spLocks noGrp="1"/>
           </p:cNvSpPr>
@@ -945,7 +825,7 @@
     </p:spTree>
     <p:extLst>
       <p:ext uri="{BB962C8B-B14F-4D97-AF65-F5344CB8AC3E}">
-        <p14:creationId xmlns:p14="http://schemas.microsoft.com/office/powerpoint/2010/main" val="3728528293"/>
+        <p14:creationId xmlns:p14="http://schemas.microsoft.com/office/powerpoint/2010/main" val="1343802147"/>
       </p:ext>
     </p:extLst>
   </p:cSld>
@@ -974,13 +854,7 @@
       </p:grpSpPr>
       <p:sp>
         <p:nvSpPr>
-          <p:cNvPr id="2" name="Title 1">
-            <a:extLst>
-              <a:ext uri="{FF2B5EF4-FFF2-40B4-BE49-F238E27FC236}">
-                <a16:creationId xmlns:a16="http://schemas.microsoft.com/office/drawing/2014/main" id="{30FB4905-4E3D-8B24-9911-5F9F8CEE6E8C}"/>
-              </a:ext>
-            </a:extLst>
-          </p:cNvPr>
+          <p:cNvPr id="2" name="Title 1"/>
           <p:cNvSpPr>
             <a:spLocks noGrp="1"/>
           </p:cNvSpPr>
@@ -990,15 +864,15 @@
         </p:nvSpPr>
         <p:spPr>
           <a:xfrm>
-            <a:off x="831850" y="1709738"/>
-            <a:ext cx="10515600" cy="2852737"/>
+            <a:off x="614031" y="1476233"/>
+            <a:ext cx="7762102" cy="2463127"/>
           </a:xfrm>
         </p:spPr>
         <p:txBody>
           <a:bodyPr anchor="b"/>
           <a:lstStyle>
             <a:lvl1pPr>
-              <a:defRPr sz="6000"/>
+              <a:defRPr sz="5180"/>
             </a:lvl1pPr>
           </a:lstStyle>
           <a:p>
@@ -1006,19 +880,13 @@
               <a:rPr lang="en-GB"/>
               <a:t>Click to edit Master title style</a:t>
             </a:r>
-            <a:endParaRPr lang="en-US"/>
-          </a:p>
-        </p:txBody>
-      </p:sp>
-      <p:sp>
-        <p:nvSpPr>
-          <p:cNvPr id="3" name="Text Placeholder 2">
-            <a:extLst>
-              <a:ext uri="{FF2B5EF4-FFF2-40B4-BE49-F238E27FC236}">
-                <a16:creationId xmlns:a16="http://schemas.microsoft.com/office/drawing/2014/main" id="{C5A97076-9EAA-E7FA-F260-B5972BF3A080}"/>
-              </a:ext>
-            </a:extLst>
-          </p:cNvPr>
+            <a:endParaRPr lang="en-US" dirty="0"/>
+          </a:p>
+        </p:txBody>
+      </p:sp>
+      <p:sp>
+        <p:nvSpPr>
+          <p:cNvPr id="3" name="Text Placeholder 2"/>
           <p:cNvSpPr>
             <a:spLocks noGrp="1"/>
           </p:cNvSpPr>
@@ -1028,8 +896,8 @@
         </p:nvSpPr>
         <p:spPr>
           <a:xfrm>
-            <a:off x="831850" y="4589463"/>
-            <a:ext cx="10515600" cy="1500187"/>
+            <a:off x="614031" y="3962663"/>
+            <a:ext cx="7762102" cy="1295300"/>
           </a:xfrm>
         </p:spPr>
         <p:txBody>
@@ -1037,7 +905,7 @@
           <a:lstStyle>
             <a:lvl1pPr marL="0" indent="0">
               <a:buNone/>
-              <a:defRPr sz="2400">
+              <a:defRPr sz="2072">
                 <a:solidFill>
                   <a:schemeClr val="tx1">
                     <a:tint val="82000"/>
@@ -1045,9 +913,9 @@
                 </a:solidFill>
               </a:defRPr>
             </a:lvl1pPr>
-            <a:lvl2pPr marL="457200" indent="0">
-              <a:buNone/>
-              <a:defRPr sz="2000">
+            <a:lvl2pPr marL="394746" indent="0">
+              <a:buNone/>
+              <a:defRPr sz="1727">
                 <a:solidFill>
                   <a:schemeClr val="tx1">
                     <a:tint val="82000"/>
@@ -1055,9 +923,9 @@
                 </a:solidFill>
               </a:defRPr>
             </a:lvl2pPr>
-            <a:lvl3pPr marL="914400" indent="0">
-              <a:buNone/>
-              <a:defRPr sz="1800">
+            <a:lvl3pPr marL="789493" indent="0">
+              <a:buNone/>
+              <a:defRPr sz="1554">
                 <a:solidFill>
                   <a:schemeClr val="tx1">
                     <a:tint val="82000"/>
@@ -1065,9 +933,9 @@
                 </a:solidFill>
               </a:defRPr>
             </a:lvl3pPr>
-            <a:lvl4pPr marL="1371600" indent="0">
-              <a:buNone/>
-              <a:defRPr sz="1600">
+            <a:lvl4pPr marL="1184239" indent="0">
+              <a:buNone/>
+              <a:defRPr sz="1381">
                 <a:solidFill>
                   <a:schemeClr val="tx1">
                     <a:tint val="82000"/>
@@ -1075,9 +943,9 @@
                 </a:solidFill>
               </a:defRPr>
             </a:lvl4pPr>
-            <a:lvl5pPr marL="1828800" indent="0">
-              <a:buNone/>
-              <a:defRPr sz="1600">
+            <a:lvl5pPr marL="1578986" indent="0">
+              <a:buNone/>
+              <a:defRPr sz="1381">
                 <a:solidFill>
                   <a:schemeClr val="tx1">
                     <a:tint val="82000"/>
@@ -1085,9 +953,9 @@
                 </a:solidFill>
               </a:defRPr>
             </a:lvl5pPr>
-            <a:lvl6pPr marL="2286000" indent="0">
-              <a:buNone/>
-              <a:defRPr sz="1600">
+            <a:lvl6pPr marL="1973732" indent="0">
+              <a:buNone/>
+              <a:defRPr sz="1381">
                 <a:solidFill>
                   <a:schemeClr val="tx1">
                     <a:tint val="82000"/>
@@ -1095,9 +963,9 @@
                 </a:solidFill>
               </a:defRPr>
             </a:lvl6pPr>
-            <a:lvl7pPr marL="2743200" indent="0">
-              <a:buNone/>
-              <a:defRPr sz="1600">
+            <a:lvl7pPr marL="2368479" indent="0">
+              <a:buNone/>
+              <a:defRPr sz="1381">
                 <a:solidFill>
                   <a:schemeClr val="tx1">
                     <a:tint val="82000"/>
@@ -1105,9 +973,9 @@
                 </a:solidFill>
               </a:defRPr>
             </a:lvl7pPr>
-            <a:lvl8pPr marL="3200400" indent="0">
-              <a:buNone/>
-              <a:defRPr sz="1600">
+            <a:lvl8pPr marL="2763225" indent="0">
+              <a:buNone/>
+              <a:defRPr sz="1381">
                 <a:solidFill>
                   <a:schemeClr val="tx1">
                     <a:tint val="82000"/>
@@ -1115,9 +983,9 @@
                 </a:solidFill>
               </a:defRPr>
             </a:lvl8pPr>
-            <a:lvl9pPr marL="3657600" indent="0">
-              <a:buNone/>
-              <a:defRPr sz="1600">
+            <a:lvl9pPr marL="3157972" indent="0">
+              <a:buNone/>
+              <a:defRPr sz="1381">
                 <a:solidFill>
                   <a:schemeClr val="tx1">
                     <a:tint val="82000"/>
@@ -1137,13 +1005,7 @@
       </p:sp>
       <p:sp>
         <p:nvSpPr>
-          <p:cNvPr id="4" name="Date Placeholder 3">
-            <a:extLst>
-              <a:ext uri="{FF2B5EF4-FFF2-40B4-BE49-F238E27FC236}">
-                <a16:creationId xmlns:a16="http://schemas.microsoft.com/office/drawing/2014/main" id="{63A5CD27-F592-7204-5F55-55BB677248B8}"/>
-              </a:ext>
-            </a:extLst>
-          </p:cNvPr>
+          <p:cNvPr id="4" name="Date Placeholder 3"/>
           <p:cNvSpPr>
             <a:spLocks noGrp="1"/>
           </p:cNvSpPr>
@@ -1158,7 +1020,7 @@
           <a:p>
             <a:fld id="{918BE157-C9BD-DB4B-B849-501D8C18A188}" type="datetimeFigureOut">
               <a:rPr lang="en-US" smtClean="0"/>
-              <a:t>6/2/26</a:t>
+              <a:t>9/9/26</a:t>
             </a:fld>
             <a:endParaRPr lang="en-US"/>
           </a:p>
@@ -1166,13 +1028,7 @@
       </p:sp>
       <p:sp>
         <p:nvSpPr>
-          <p:cNvPr id="5" name="Footer Placeholder 4">
-            <a:extLst>
-              <a:ext uri="{FF2B5EF4-FFF2-40B4-BE49-F238E27FC236}">
-                <a16:creationId xmlns:a16="http://schemas.microsoft.com/office/drawing/2014/main" id="{A92F980E-3AB7-0C7C-98B5-758C2CCDF4F1}"/>
-              </a:ext>
-            </a:extLst>
-          </p:cNvPr>
+          <p:cNvPr id="5" name="Footer Placeholder 4"/>
           <p:cNvSpPr>
             <a:spLocks noGrp="1"/>
           </p:cNvSpPr>
@@ -1191,13 +1047,7 @@
       </p:sp>
       <p:sp>
         <p:nvSpPr>
-          <p:cNvPr id="6" name="Slide Number Placeholder 5">
-            <a:extLst>
-              <a:ext uri="{FF2B5EF4-FFF2-40B4-BE49-F238E27FC236}">
-                <a16:creationId xmlns:a16="http://schemas.microsoft.com/office/drawing/2014/main" id="{49BA8C76-DB41-9791-E7E0-771DEB57422B}"/>
-              </a:ext>
-            </a:extLst>
-          </p:cNvPr>
+          <p:cNvPr id="6" name="Slide Number Placeholder 5"/>
           <p:cNvSpPr>
             <a:spLocks noGrp="1"/>
           </p:cNvSpPr>
@@ -1221,7 +1071,7 @@
     </p:spTree>
     <p:extLst>
       <p:ext uri="{BB962C8B-B14F-4D97-AF65-F5344CB8AC3E}">
-        <p14:creationId xmlns:p14="http://schemas.microsoft.com/office/powerpoint/2010/main" val="4239974110"/>
+        <p14:creationId xmlns:p14="http://schemas.microsoft.com/office/powerpoint/2010/main" val="3324487146"/>
       </p:ext>
     </p:extLst>
   </p:cSld>
@@ -1250,13 +1100,7 @@
       </p:grpSpPr>
       <p:sp>
         <p:nvSpPr>
-          <p:cNvPr id="2" name="Title 1">
-            <a:extLst>
-              <a:ext uri="{FF2B5EF4-FFF2-40B4-BE49-F238E27FC236}">
-                <a16:creationId xmlns:a16="http://schemas.microsoft.com/office/drawing/2014/main" id="{884C4A78-C746-9923-0DA3-199F84E4167A}"/>
-              </a:ext>
-            </a:extLst>
-          </p:cNvPr>
+          <p:cNvPr id="2" name="Title 1"/>
           <p:cNvSpPr>
             <a:spLocks noGrp="1"/>
           </p:cNvSpPr>
@@ -1273,19 +1117,13 @@
               <a:rPr lang="en-GB"/>
               <a:t>Click to edit Master title style</a:t>
             </a:r>
-            <a:endParaRPr lang="en-US"/>
-          </a:p>
-        </p:txBody>
-      </p:sp>
-      <p:sp>
-        <p:nvSpPr>
-          <p:cNvPr id="3" name="Content Placeholder 2">
-            <a:extLst>
-              <a:ext uri="{FF2B5EF4-FFF2-40B4-BE49-F238E27FC236}">
-                <a16:creationId xmlns:a16="http://schemas.microsoft.com/office/drawing/2014/main" id="{DB3DAC84-FA74-993E-E4F4-9426EC98B055}"/>
-              </a:ext>
-            </a:extLst>
-          </p:cNvPr>
+            <a:endParaRPr lang="en-US" dirty="0"/>
+          </a:p>
+        </p:txBody>
+      </p:sp>
+      <p:sp>
+        <p:nvSpPr>
+          <p:cNvPr id="3" name="Content Placeholder 2"/>
           <p:cNvSpPr>
             <a:spLocks noGrp="1"/>
           </p:cNvSpPr>
@@ -1295,8 +1133,8 @@
         </p:nvSpPr>
         <p:spPr>
           <a:xfrm>
-            <a:off x="838200" y="1825625"/>
-            <a:ext cx="5181600" cy="4351338"/>
+            <a:off x="618718" y="1576292"/>
+            <a:ext cx="3824804" cy="3757058"/>
           </a:xfrm>
         </p:spPr>
         <p:txBody>
@@ -1336,19 +1174,13 @@
               <a:rPr lang="en-GB"/>
               <a:t>Fifth level</a:t>
             </a:r>
-            <a:endParaRPr lang="en-US"/>
-          </a:p>
-        </p:txBody>
-      </p:sp>
-      <p:sp>
-        <p:nvSpPr>
-          <p:cNvPr id="4" name="Content Placeholder 3">
-            <a:extLst>
-              <a:ext uri="{FF2B5EF4-FFF2-40B4-BE49-F238E27FC236}">
-                <a16:creationId xmlns:a16="http://schemas.microsoft.com/office/drawing/2014/main" id="{6079C02D-48A2-5262-3BF4-ADBF69DB8436}"/>
-              </a:ext>
-            </a:extLst>
-          </p:cNvPr>
+            <a:endParaRPr lang="en-US" dirty="0"/>
+          </a:p>
+        </p:txBody>
+      </p:sp>
+      <p:sp>
+        <p:nvSpPr>
+          <p:cNvPr id="4" name="Content Placeholder 3"/>
           <p:cNvSpPr>
             <a:spLocks noGrp="1"/>
           </p:cNvSpPr>
@@ -1358,8 +1190,8 @@
         </p:nvSpPr>
         <p:spPr>
           <a:xfrm>
-            <a:off x="6172200" y="1825625"/>
-            <a:ext cx="5181600" cy="4351338"/>
+            <a:off x="4556016" y="1576292"/>
+            <a:ext cx="3824804" cy="3757058"/>
           </a:xfrm>
         </p:spPr>
         <p:txBody>
@@ -1399,19 +1231,13 @@
               <a:rPr lang="en-GB"/>
               <a:t>Fifth level</a:t>
             </a:r>
-            <a:endParaRPr lang="en-US"/>
-          </a:p>
-        </p:txBody>
-      </p:sp>
-      <p:sp>
-        <p:nvSpPr>
-          <p:cNvPr id="5" name="Date Placeholder 4">
-            <a:extLst>
-              <a:ext uri="{FF2B5EF4-FFF2-40B4-BE49-F238E27FC236}">
-                <a16:creationId xmlns:a16="http://schemas.microsoft.com/office/drawing/2014/main" id="{FD749F54-CCED-FCE9-AA59-4E27FD8DFCEE}"/>
-              </a:ext>
-            </a:extLst>
-          </p:cNvPr>
+            <a:endParaRPr lang="en-US" dirty="0"/>
+          </a:p>
+        </p:txBody>
+      </p:sp>
+      <p:sp>
+        <p:nvSpPr>
+          <p:cNvPr id="5" name="Date Placeholder 4"/>
           <p:cNvSpPr>
             <a:spLocks noGrp="1"/>
           </p:cNvSpPr>
@@ -1426,7 +1252,7 @@
           <a:p>
             <a:fld id="{918BE157-C9BD-DB4B-B849-501D8C18A188}" type="datetimeFigureOut">
               <a:rPr lang="en-US" smtClean="0"/>
-              <a:t>6/2/26</a:t>
+              <a:t>9/9/26</a:t>
             </a:fld>
             <a:endParaRPr lang="en-US"/>
           </a:p>
@@ -1434,13 +1260,7 @@
       </p:sp>
       <p:sp>
         <p:nvSpPr>
-          <p:cNvPr id="6" name="Footer Placeholder 5">
-            <a:extLst>
-              <a:ext uri="{FF2B5EF4-FFF2-40B4-BE49-F238E27FC236}">
-                <a16:creationId xmlns:a16="http://schemas.microsoft.com/office/drawing/2014/main" id="{EB66DCCF-04F2-57AC-2523-61CBD8AE72EE}"/>
-              </a:ext>
-            </a:extLst>
-          </p:cNvPr>
+          <p:cNvPr id="6" name="Footer Placeholder 5"/>
           <p:cNvSpPr>
             <a:spLocks noGrp="1"/>
           </p:cNvSpPr>
@@ -1459,13 +1279,7 @@
       </p:sp>
       <p:sp>
         <p:nvSpPr>
-          <p:cNvPr id="7" name="Slide Number Placeholder 6">
-            <a:extLst>
-              <a:ext uri="{FF2B5EF4-FFF2-40B4-BE49-F238E27FC236}">
-                <a16:creationId xmlns:a16="http://schemas.microsoft.com/office/drawing/2014/main" id="{A3213D99-6370-A092-28DC-F9B19B0D79D1}"/>
-              </a:ext>
-            </a:extLst>
-          </p:cNvPr>
+          <p:cNvPr id="7" name="Slide Number Placeholder 6"/>
           <p:cNvSpPr>
             <a:spLocks noGrp="1"/>
           </p:cNvSpPr>
@@ -1489,7 +1303,7 @@
     </p:spTree>
     <p:extLst>
       <p:ext uri="{BB962C8B-B14F-4D97-AF65-F5344CB8AC3E}">
-        <p14:creationId xmlns:p14="http://schemas.microsoft.com/office/powerpoint/2010/main" val="3959556756"/>
+        <p14:creationId xmlns:p14="http://schemas.microsoft.com/office/powerpoint/2010/main" val="2883792210"/>
       </p:ext>
     </p:extLst>
   </p:cSld>
@@ -1518,13 +1332,7 @@
       </p:grpSpPr>
       <p:sp>
         <p:nvSpPr>
-          <p:cNvPr id="2" name="Title 1">
-            <a:extLst>
-              <a:ext uri="{FF2B5EF4-FFF2-40B4-BE49-F238E27FC236}">
-                <a16:creationId xmlns:a16="http://schemas.microsoft.com/office/drawing/2014/main" id="{3629484E-A127-486F-231F-AF5F18F563AE}"/>
-              </a:ext>
-            </a:extLst>
-          </p:cNvPr>
+          <p:cNvPr id="2" name="Title 1"/>
           <p:cNvSpPr>
             <a:spLocks noGrp="1"/>
           </p:cNvSpPr>
@@ -1534,8 +1342,8 @@
         </p:nvSpPr>
         <p:spPr>
           <a:xfrm>
-            <a:off x="839788" y="365125"/>
-            <a:ext cx="10515600" cy="1325563"/>
+            <a:off x="619890" y="315260"/>
+            <a:ext cx="7762102" cy="1144525"/>
           </a:xfrm>
         </p:spPr>
         <p:txBody>
@@ -1546,19 +1354,13 @@
               <a:rPr lang="en-GB"/>
               <a:t>Click to edit Master title style</a:t>
             </a:r>
-            <a:endParaRPr lang="en-US"/>
-          </a:p>
-        </p:txBody>
-      </p:sp>
-      <p:sp>
-        <p:nvSpPr>
-          <p:cNvPr id="3" name="Text Placeholder 2">
-            <a:extLst>
-              <a:ext uri="{FF2B5EF4-FFF2-40B4-BE49-F238E27FC236}">
-                <a16:creationId xmlns:a16="http://schemas.microsoft.com/office/drawing/2014/main" id="{ED8BE184-E7BB-BFFF-20D2-F6234325CA54}"/>
-              </a:ext>
-            </a:extLst>
-          </p:cNvPr>
+            <a:endParaRPr lang="en-US" dirty="0"/>
+          </a:p>
+        </p:txBody>
+      </p:sp>
+      <p:sp>
+        <p:nvSpPr>
+          <p:cNvPr id="3" name="Text Placeholder 2"/>
           <p:cNvSpPr>
             <a:spLocks noGrp="1"/>
           </p:cNvSpPr>
@@ -1568,8 +1370,8 @@
         </p:nvSpPr>
         <p:spPr>
           <a:xfrm>
-            <a:off x="839788" y="1681163"/>
-            <a:ext cx="5157787" cy="823912"/>
+            <a:off x="619891" y="1451560"/>
+            <a:ext cx="3807226" cy="711387"/>
           </a:xfrm>
         </p:spPr>
         <p:txBody>
@@ -1577,39 +1379,39 @@
           <a:lstStyle>
             <a:lvl1pPr marL="0" indent="0">
               <a:buNone/>
-              <a:defRPr sz="2400" b="1"/>
+              <a:defRPr sz="2072" b="1"/>
             </a:lvl1pPr>
-            <a:lvl2pPr marL="457200" indent="0">
-              <a:buNone/>
-              <a:defRPr sz="2000" b="1"/>
+            <a:lvl2pPr marL="394746" indent="0">
+              <a:buNone/>
+              <a:defRPr sz="1727" b="1"/>
             </a:lvl2pPr>
-            <a:lvl3pPr marL="914400" indent="0">
-              <a:buNone/>
-              <a:defRPr sz="1800" b="1"/>
+            <a:lvl3pPr marL="789493" indent="0">
+              <a:buNone/>
+              <a:defRPr sz="1554" b="1"/>
             </a:lvl3pPr>
-            <a:lvl4pPr marL="1371600" indent="0">
-              <a:buNone/>
-              <a:defRPr sz="1600" b="1"/>
+            <a:lvl4pPr marL="1184239" indent="0">
+              <a:buNone/>
+              <a:defRPr sz="1381" b="1"/>
             </a:lvl4pPr>
-            <a:lvl5pPr marL="1828800" indent="0">
-              <a:buNone/>
-              <a:defRPr sz="1600" b="1"/>
+            <a:lvl5pPr marL="1578986" indent="0">
+              <a:buNone/>
+              <a:defRPr sz="1381" b="1"/>
             </a:lvl5pPr>
-            <a:lvl6pPr marL="2286000" indent="0">
-              <a:buNone/>
-              <a:defRPr sz="1600" b="1"/>
+            <a:lvl6pPr marL="1973732" indent="0">
+              <a:buNone/>
+              <a:defRPr sz="1381" b="1"/>
             </a:lvl6pPr>
-            <a:lvl7pPr marL="2743200" indent="0">
-              <a:buNone/>
-              <a:defRPr sz="1600" b="1"/>
+            <a:lvl7pPr marL="2368479" indent="0">
+              <a:buNone/>
+              <a:defRPr sz="1381" b="1"/>
             </a:lvl7pPr>
-            <a:lvl8pPr marL="3200400" indent="0">
-              <a:buNone/>
-              <a:defRPr sz="1600" b="1"/>
+            <a:lvl8pPr marL="2763225" indent="0">
+              <a:buNone/>
+              <a:defRPr sz="1381" b="1"/>
             </a:lvl8pPr>
-            <a:lvl9pPr marL="3657600" indent="0">
-              <a:buNone/>
-              <a:defRPr sz="1600" b="1"/>
+            <a:lvl9pPr marL="3157972" indent="0">
+              <a:buNone/>
+              <a:defRPr sz="1381" b="1"/>
             </a:lvl9pPr>
           </a:lstStyle>
           <a:p>
@@ -1623,13 +1425,7 @@
       </p:sp>
       <p:sp>
         <p:nvSpPr>
-          <p:cNvPr id="4" name="Content Placeholder 3">
-            <a:extLst>
-              <a:ext uri="{FF2B5EF4-FFF2-40B4-BE49-F238E27FC236}">
-                <a16:creationId xmlns:a16="http://schemas.microsoft.com/office/drawing/2014/main" id="{C290A398-FAC2-FE6C-F84E-70892368A7FA}"/>
-              </a:ext>
-            </a:extLst>
-          </p:cNvPr>
+          <p:cNvPr id="4" name="Content Placeholder 3"/>
           <p:cNvSpPr>
             <a:spLocks noGrp="1"/>
           </p:cNvSpPr>
@@ -1639,8 +1435,8 @@
         </p:nvSpPr>
         <p:spPr>
           <a:xfrm>
-            <a:off x="839788" y="2505075"/>
-            <a:ext cx="5157787" cy="3684588"/>
+            <a:off x="619891" y="2162947"/>
+            <a:ext cx="3807226" cy="3181369"/>
           </a:xfrm>
         </p:spPr>
         <p:txBody>
@@ -1680,19 +1476,13 @@
               <a:rPr lang="en-GB"/>
               <a:t>Fifth level</a:t>
             </a:r>
-            <a:endParaRPr lang="en-US"/>
-          </a:p>
-        </p:txBody>
-      </p:sp>
-      <p:sp>
-        <p:nvSpPr>
-          <p:cNvPr id="5" name="Text Placeholder 4">
-            <a:extLst>
-              <a:ext uri="{FF2B5EF4-FFF2-40B4-BE49-F238E27FC236}">
-                <a16:creationId xmlns:a16="http://schemas.microsoft.com/office/drawing/2014/main" id="{374AD717-445A-46CD-E845-EFAB4204C736}"/>
-              </a:ext>
-            </a:extLst>
-          </p:cNvPr>
+            <a:endParaRPr lang="en-US" dirty="0"/>
+          </a:p>
+        </p:txBody>
+      </p:sp>
+      <p:sp>
+        <p:nvSpPr>
+          <p:cNvPr id="5" name="Text Placeholder 4"/>
           <p:cNvSpPr>
             <a:spLocks noGrp="1"/>
           </p:cNvSpPr>
@@ -1702,8 +1492,8 @@
         </p:nvSpPr>
         <p:spPr>
           <a:xfrm>
-            <a:off x="6172200" y="1681163"/>
-            <a:ext cx="5183188" cy="823912"/>
+            <a:off x="4556017" y="1451560"/>
+            <a:ext cx="3825976" cy="711387"/>
           </a:xfrm>
         </p:spPr>
         <p:txBody>
@@ -1711,39 +1501,39 @@
           <a:lstStyle>
             <a:lvl1pPr marL="0" indent="0">
               <a:buNone/>
-              <a:defRPr sz="2400" b="1"/>
+              <a:defRPr sz="2072" b="1"/>
             </a:lvl1pPr>
-            <a:lvl2pPr marL="457200" indent="0">
-              <a:buNone/>
-              <a:defRPr sz="2000" b="1"/>
+            <a:lvl2pPr marL="394746" indent="0">
+              <a:buNone/>
+              <a:defRPr sz="1727" b="1"/>
             </a:lvl2pPr>
-            <a:lvl3pPr marL="914400" indent="0">
-              <a:buNone/>
-              <a:defRPr sz="1800" b="1"/>
+            <a:lvl3pPr marL="789493" indent="0">
+              <a:buNone/>
+              <a:defRPr sz="1554" b="1"/>
             </a:lvl3pPr>
-            <a:lvl4pPr marL="1371600" indent="0">
-              <a:buNone/>
-              <a:defRPr sz="1600" b="1"/>
+            <a:lvl4pPr marL="1184239" indent="0">
+              <a:buNone/>
+              <a:defRPr sz="1381" b="1"/>
             </a:lvl4pPr>
-            <a:lvl5pPr marL="1828800" indent="0">
-              <a:buNone/>
-              <a:defRPr sz="1600" b="1"/>
+            <a:lvl5pPr marL="1578986" indent="0">
+              <a:buNone/>
+              <a:defRPr sz="1381" b="1"/>
             </a:lvl5pPr>
-            <a:lvl6pPr marL="2286000" indent="0">
-              <a:buNone/>
-              <a:defRPr sz="1600" b="1"/>
+            <a:lvl6pPr marL="1973732" indent="0">
+              <a:buNone/>
+              <a:defRPr sz="1381" b="1"/>
             </a:lvl6pPr>
-            <a:lvl7pPr marL="2743200" indent="0">
-              <a:buNone/>
-              <a:defRPr sz="1600" b="1"/>
+            <a:lvl7pPr marL="2368479" indent="0">
+              <a:buNone/>
+              <a:defRPr sz="1381" b="1"/>
             </a:lvl7pPr>
-            <a:lvl8pPr marL="3200400" indent="0">
-              <a:buNone/>
-              <a:defRPr sz="1600" b="1"/>
+            <a:lvl8pPr marL="2763225" indent="0">
+              <a:buNone/>
+              <a:defRPr sz="1381" b="1"/>
             </a:lvl8pPr>
-            <a:lvl9pPr marL="3657600" indent="0">
-              <a:buNone/>
-              <a:defRPr sz="1600" b="1"/>
+            <a:lvl9pPr marL="3157972" indent="0">
+              <a:buNone/>
+              <a:defRPr sz="1381" b="1"/>
             </a:lvl9pPr>
           </a:lstStyle>
           <a:p>
@@ -1757,13 +1547,7 @@
       </p:sp>
       <p:sp>
         <p:nvSpPr>
-          <p:cNvPr id="6" name="Content Placeholder 5">
-            <a:extLst>
-              <a:ext uri="{FF2B5EF4-FFF2-40B4-BE49-F238E27FC236}">
-                <a16:creationId xmlns:a16="http://schemas.microsoft.com/office/drawing/2014/main" id="{8704D235-16FF-E508-D089-162D6B4607B0}"/>
-              </a:ext>
-            </a:extLst>
-          </p:cNvPr>
+          <p:cNvPr id="6" name="Content Placeholder 5"/>
           <p:cNvSpPr>
             <a:spLocks noGrp="1"/>
           </p:cNvSpPr>
@@ -1773,8 +1557,8 @@
         </p:nvSpPr>
         <p:spPr>
           <a:xfrm>
-            <a:off x="6172200" y="2505075"/>
-            <a:ext cx="5183188" cy="3684588"/>
+            <a:off x="4556017" y="2162947"/>
+            <a:ext cx="3825976" cy="3181369"/>
           </a:xfrm>
         </p:spPr>
         <p:txBody>
@@ -1814,19 +1598,13 @@
               <a:rPr lang="en-GB"/>
               <a:t>Fifth level</a:t>
             </a:r>
-            <a:endParaRPr lang="en-US"/>
-          </a:p>
-        </p:txBody>
-      </p:sp>
-      <p:sp>
-        <p:nvSpPr>
-          <p:cNvPr id="7" name="Date Placeholder 6">
-            <a:extLst>
-              <a:ext uri="{FF2B5EF4-FFF2-40B4-BE49-F238E27FC236}">
-                <a16:creationId xmlns:a16="http://schemas.microsoft.com/office/drawing/2014/main" id="{653F9B75-85D0-24F4-DD19-BC4D21E87E96}"/>
-              </a:ext>
-            </a:extLst>
-          </p:cNvPr>
+            <a:endParaRPr lang="en-US" dirty="0"/>
+          </a:p>
+        </p:txBody>
+      </p:sp>
+      <p:sp>
+        <p:nvSpPr>
+          <p:cNvPr id="7" name="Date Placeholder 6"/>
           <p:cNvSpPr>
             <a:spLocks noGrp="1"/>
           </p:cNvSpPr>
@@ -1841,7 +1619,7 @@
           <a:p>
             <a:fld id="{918BE157-C9BD-DB4B-B849-501D8C18A188}" type="datetimeFigureOut">
               <a:rPr lang="en-US" smtClean="0"/>
-              <a:t>6/2/26</a:t>
+              <a:t>9/9/26</a:t>
             </a:fld>
             <a:endParaRPr lang="en-US"/>
           </a:p>
@@ -1849,13 +1627,7 @@
       </p:sp>
       <p:sp>
         <p:nvSpPr>
-          <p:cNvPr id="8" name="Footer Placeholder 7">
-            <a:extLst>
-              <a:ext uri="{FF2B5EF4-FFF2-40B4-BE49-F238E27FC236}">
-                <a16:creationId xmlns:a16="http://schemas.microsoft.com/office/drawing/2014/main" id="{3DDBE324-2FCC-787C-A822-9066100D4E2B}"/>
-              </a:ext>
-            </a:extLst>
-          </p:cNvPr>
+          <p:cNvPr id="8" name="Footer Placeholder 7"/>
           <p:cNvSpPr>
             <a:spLocks noGrp="1"/>
           </p:cNvSpPr>
@@ -1874,13 +1646,7 @@
       </p:sp>
       <p:sp>
         <p:nvSpPr>
-          <p:cNvPr id="9" name="Slide Number Placeholder 8">
-            <a:extLst>
-              <a:ext uri="{FF2B5EF4-FFF2-40B4-BE49-F238E27FC236}">
-                <a16:creationId xmlns:a16="http://schemas.microsoft.com/office/drawing/2014/main" id="{0B295979-FAA2-B40D-6F38-753C7E0FED22}"/>
-              </a:ext>
-            </a:extLst>
-          </p:cNvPr>
+          <p:cNvPr id="9" name="Slide Number Placeholder 8"/>
           <p:cNvSpPr>
             <a:spLocks noGrp="1"/>
           </p:cNvSpPr>
@@ -1904,7 +1670,7 @@
     </p:spTree>
     <p:extLst>
       <p:ext uri="{BB962C8B-B14F-4D97-AF65-F5344CB8AC3E}">
-        <p14:creationId xmlns:p14="http://schemas.microsoft.com/office/powerpoint/2010/main" val="3019715483"/>
+        <p14:creationId xmlns:p14="http://schemas.microsoft.com/office/powerpoint/2010/main" val="4022913658"/>
       </p:ext>
     </p:extLst>
   </p:cSld>
@@ -1933,13 +1699,7 @@
       </p:grpSpPr>
       <p:sp>
         <p:nvSpPr>
-          <p:cNvPr id="2" name="Title 1">
-            <a:extLst>
-              <a:ext uri="{FF2B5EF4-FFF2-40B4-BE49-F238E27FC236}">
-                <a16:creationId xmlns:a16="http://schemas.microsoft.com/office/drawing/2014/main" id="{6DD83239-999D-1A31-52EA-BEABE56A7DCB}"/>
-              </a:ext>
-            </a:extLst>
-          </p:cNvPr>
+          <p:cNvPr id="2" name="Title 1"/>
           <p:cNvSpPr>
             <a:spLocks noGrp="1"/>
           </p:cNvSpPr>
@@ -1956,19 +1716,13 @@
               <a:rPr lang="en-GB"/>
               <a:t>Click to edit Master title style</a:t>
             </a:r>
-            <a:endParaRPr lang="en-US"/>
-          </a:p>
-        </p:txBody>
-      </p:sp>
-      <p:sp>
-        <p:nvSpPr>
-          <p:cNvPr id="3" name="Date Placeholder 2">
-            <a:extLst>
-              <a:ext uri="{FF2B5EF4-FFF2-40B4-BE49-F238E27FC236}">
-                <a16:creationId xmlns:a16="http://schemas.microsoft.com/office/drawing/2014/main" id="{665F9B13-30B7-52A4-739A-27655CEF7FAF}"/>
-              </a:ext>
-            </a:extLst>
-          </p:cNvPr>
+            <a:endParaRPr lang="en-US" dirty="0"/>
+          </a:p>
+        </p:txBody>
+      </p:sp>
+      <p:sp>
+        <p:nvSpPr>
+          <p:cNvPr id="3" name="Date Placeholder 2"/>
           <p:cNvSpPr>
             <a:spLocks noGrp="1"/>
           </p:cNvSpPr>
@@ -1983,7 +1737,7 @@
           <a:p>
             <a:fld id="{918BE157-C9BD-DB4B-B849-501D8C18A188}" type="datetimeFigureOut">
               <a:rPr lang="en-US" smtClean="0"/>
-              <a:t>6/2/26</a:t>
+              <a:t>9/9/26</a:t>
             </a:fld>
             <a:endParaRPr lang="en-US"/>
           </a:p>
@@ -1991,13 +1745,7 @@
       </p:sp>
       <p:sp>
         <p:nvSpPr>
-          <p:cNvPr id="4" name="Footer Placeholder 3">
-            <a:extLst>
-              <a:ext uri="{FF2B5EF4-FFF2-40B4-BE49-F238E27FC236}">
-                <a16:creationId xmlns:a16="http://schemas.microsoft.com/office/drawing/2014/main" id="{31351E83-7651-8273-8E88-7117C8DBEB15}"/>
-              </a:ext>
-            </a:extLst>
-          </p:cNvPr>
+          <p:cNvPr id="4" name="Footer Placeholder 3"/>
           <p:cNvSpPr>
             <a:spLocks noGrp="1"/>
           </p:cNvSpPr>
@@ -2016,13 +1764,7 @@
       </p:sp>
       <p:sp>
         <p:nvSpPr>
-          <p:cNvPr id="5" name="Slide Number Placeholder 4">
-            <a:extLst>
-              <a:ext uri="{FF2B5EF4-FFF2-40B4-BE49-F238E27FC236}">
-                <a16:creationId xmlns:a16="http://schemas.microsoft.com/office/drawing/2014/main" id="{ED535482-99D1-C984-2111-637C8EC14CC4}"/>
-              </a:ext>
-            </a:extLst>
-          </p:cNvPr>
+          <p:cNvPr id="5" name="Slide Number Placeholder 4"/>
           <p:cNvSpPr>
             <a:spLocks noGrp="1"/>
           </p:cNvSpPr>
@@ -2046,7 +1788,7 @@
     </p:spTree>
     <p:extLst>
       <p:ext uri="{BB962C8B-B14F-4D97-AF65-F5344CB8AC3E}">
-        <p14:creationId xmlns:p14="http://schemas.microsoft.com/office/powerpoint/2010/main" val="1371233815"/>
+        <p14:creationId xmlns:p14="http://schemas.microsoft.com/office/powerpoint/2010/main" val="3601778197"/>
       </p:ext>
     </p:extLst>
   </p:cSld>
@@ -2075,13 +1817,7 @@
       </p:grpSpPr>
       <p:sp>
         <p:nvSpPr>
-          <p:cNvPr id="2" name="Date Placeholder 1">
-            <a:extLst>
-              <a:ext uri="{FF2B5EF4-FFF2-40B4-BE49-F238E27FC236}">
-                <a16:creationId xmlns:a16="http://schemas.microsoft.com/office/drawing/2014/main" id="{89E3A77F-6397-4BBE-BDDA-483C46379EE4}"/>
-              </a:ext>
-            </a:extLst>
-          </p:cNvPr>
+          <p:cNvPr id="2" name="Date Placeholder 1"/>
           <p:cNvSpPr>
             <a:spLocks noGrp="1"/>
           </p:cNvSpPr>
@@ -2096,7 +1832,7 @@
           <a:p>
             <a:fld id="{918BE157-C9BD-DB4B-B849-501D8C18A188}" type="datetimeFigureOut">
               <a:rPr lang="en-US" smtClean="0"/>
-              <a:t>6/2/26</a:t>
+              <a:t>9/9/26</a:t>
             </a:fld>
             <a:endParaRPr lang="en-US"/>
           </a:p>
@@ -2104,13 +1840,7 @@
       </p:sp>
       <p:sp>
         <p:nvSpPr>
-          <p:cNvPr id="3" name="Footer Placeholder 2">
-            <a:extLst>
-              <a:ext uri="{FF2B5EF4-FFF2-40B4-BE49-F238E27FC236}">
-                <a16:creationId xmlns:a16="http://schemas.microsoft.com/office/drawing/2014/main" id="{D21690F1-13A1-164D-F96A-F4E0AA599FB7}"/>
-              </a:ext>
-            </a:extLst>
-          </p:cNvPr>
+          <p:cNvPr id="3" name="Footer Placeholder 2"/>
           <p:cNvSpPr>
             <a:spLocks noGrp="1"/>
           </p:cNvSpPr>
@@ -2129,13 +1859,7 @@
       </p:sp>
       <p:sp>
         <p:nvSpPr>
-          <p:cNvPr id="4" name="Slide Number Placeholder 3">
-            <a:extLst>
-              <a:ext uri="{FF2B5EF4-FFF2-40B4-BE49-F238E27FC236}">
-                <a16:creationId xmlns:a16="http://schemas.microsoft.com/office/drawing/2014/main" id="{8EEDEE3E-21B5-4719-4FF5-CEF834F5DC27}"/>
-              </a:ext>
-            </a:extLst>
-          </p:cNvPr>
+          <p:cNvPr id="4" name="Slide Number Placeholder 3"/>
           <p:cNvSpPr>
             <a:spLocks noGrp="1"/>
           </p:cNvSpPr>
@@ -2159,7 +1883,7 @@
     </p:spTree>
     <p:extLst>
       <p:ext uri="{BB962C8B-B14F-4D97-AF65-F5344CB8AC3E}">
-        <p14:creationId xmlns:p14="http://schemas.microsoft.com/office/powerpoint/2010/main" val="743777642"/>
+        <p14:creationId xmlns:p14="http://schemas.microsoft.com/office/powerpoint/2010/main" val="4091287566"/>
       </p:ext>
     </p:extLst>
   </p:cSld>
@@ -2188,13 +1912,7 @@
       </p:grpSpPr>
       <p:sp>
         <p:nvSpPr>
-          <p:cNvPr id="2" name="Title 1">
-            <a:extLst>
-              <a:ext uri="{FF2B5EF4-FFF2-40B4-BE49-F238E27FC236}">
-                <a16:creationId xmlns:a16="http://schemas.microsoft.com/office/drawing/2014/main" id="{40EE6AA4-2904-EC2C-E6A7-DF2C6817CB11}"/>
-              </a:ext>
-            </a:extLst>
-          </p:cNvPr>
+          <p:cNvPr id="2" name="Title 1"/>
           <p:cNvSpPr>
             <a:spLocks noGrp="1"/>
           </p:cNvSpPr>
@@ -2204,15 +1922,15 @@
         </p:nvSpPr>
         <p:spPr>
           <a:xfrm>
-            <a:off x="839788" y="457200"/>
-            <a:ext cx="3932237" cy="1600200"/>
+            <a:off x="619891" y="394758"/>
+            <a:ext cx="2902585" cy="1381654"/>
           </a:xfrm>
         </p:spPr>
         <p:txBody>
           <a:bodyPr anchor="b"/>
           <a:lstStyle>
             <a:lvl1pPr>
-              <a:defRPr sz="3200"/>
+              <a:defRPr sz="2763"/>
             </a:lvl1pPr>
           </a:lstStyle>
           <a:p>
@@ -2220,19 +1938,13 @@
               <a:rPr lang="en-GB"/>
               <a:t>Click to edit Master title style</a:t>
             </a:r>
-            <a:endParaRPr lang="en-US"/>
-          </a:p>
-        </p:txBody>
-      </p:sp>
-      <p:sp>
-        <p:nvSpPr>
-          <p:cNvPr id="3" name="Content Placeholder 2">
-            <a:extLst>
-              <a:ext uri="{FF2B5EF4-FFF2-40B4-BE49-F238E27FC236}">
-                <a16:creationId xmlns:a16="http://schemas.microsoft.com/office/drawing/2014/main" id="{EB3C052E-64F6-A7BA-FD6B-077E34CA0221}"/>
-              </a:ext>
-            </a:extLst>
-          </p:cNvPr>
+            <a:endParaRPr lang="en-US" dirty="0"/>
+          </a:p>
+        </p:txBody>
+      </p:sp>
+      <p:sp>
+        <p:nvSpPr>
+          <p:cNvPr id="3" name="Content Placeholder 2"/>
           <p:cNvSpPr>
             <a:spLocks noGrp="1"/>
           </p:cNvSpPr>
@@ -2242,39 +1954,39 @@
         </p:nvSpPr>
         <p:spPr>
           <a:xfrm>
-            <a:off x="5183188" y="987425"/>
-            <a:ext cx="6172200" cy="4873625"/>
+            <a:off x="3825976" y="852570"/>
+            <a:ext cx="4556016" cy="4208014"/>
           </a:xfrm>
         </p:spPr>
         <p:txBody>
           <a:bodyPr/>
           <a:lstStyle>
             <a:lvl1pPr>
-              <a:defRPr sz="3200"/>
+              <a:defRPr sz="2763"/>
             </a:lvl1pPr>
             <a:lvl2pPr>
-              <a:defRPr sz="2800"/>
+              <a:defRPr sz="2418"/>
             </a:lvl2pPr>
             <a:lvl3pPr>
-              <a:defRPr sz="2400"/>
+              <a:defRPr sz="2072"/>
             </a:lvl3pPr>
             <a:lvl4pPr>
-              <a:defRPr sz="2000"/>
+              <a:defRPr sz="1727"/>
             </a:lvl4pPr>
             <a:lvl5pPr>
-              <a:defRPr sz="2000"/>
+              <a:defRPr sz="1727"/>
             </a:lvl5pPr>
             <a:lvl6pPr>
-              <a:defRPr sz="2000"/>
+              <a:defRPr sz="1727"/>
             </a:lvl6pPr>
             <a:lvl7pPr>
-              <a:defRPr sz="2000"/>
+              <a:defRPr sz="1727"/>
             </a:lvl7pPr>
             <a:lvl8pPr>
-              <a:defRPr sz="2000"/>
+              <a:defRPr sz="1727"/>
             </a:lvl8pPr>
             <a:lvl9pPr>
-              <a:defRPr sz="2000"/>
+              <a:defRPr sz="1727"/>
             </a:lvl9pPr>
           </a:lstStyle>
           <a:p>
@@ -2311,19 +2023,13 @@
               <a:rPr lang="en-GB"/>
               <a:t>Fifth level</a:t>
             </a:r>
-            <a:endParaRPr lang="en-US"/>
-          </a:p>
-        </p:txBody>
-      </p:sp>
-      <p:sp>
-        <p:nvSpPr>
-          <p:cNvPr id="4" name="Text Placeholder 3">
-            <a:extLst>
-              <a:ext uri="{FF2B5EF4-FFF2-40B4-BE49-F238E27FC236}">
-                <a16:creationId xmlns:a16="http://schemas.microsoft.com/office/drawing/2014/main" id="{C95C439D-B23D-02C1-08D2-5D7DCAAD2257}"/>
-              </a:ext>
-            </a:extLst>
-          </p:cNvPr>
+            <a:endParaRPr lang="en-US" dirty="0"/>
+          </a:p>
+        </p:txBody>
+      </p:sp>
+      <p:sp>
+        <p:nvSpPr>
+          <p:cNvPr id="4" name="Text Placeholder 3"/>
           <p:cNvSpPr>
             <a:spLocks noGrp="1"/>
           </p:cNvSpPr>
@@ -2333,8 +2039,8 @@
         </p:nvSpPr>
         <p:spPr>
           <a:xfrm>
-            <a:off x="839788" y="2057400"/>
-            <a:ext cx="3932237" cy="3811588"/>
+            <a:off x="619891" y="1776412"/>
+            <a:ext cx="2902585" cy="3291024"/>
           </a:xfrm>
         </p:spPr>
         <p:txBody>
@@ -2342,39 +2048,39 @@
           <a:lstStyle>
             <a:lvl1pPr marL="0" indent="0">
               <a:buNone/>
-              <a:defRPr sz="1600"/>
+              <a:defRPr sz="1381"/>
             </a:lvl1pPr>
-            <a:lvl2pPr marL="457200" indent="0">
-              <a:buNone/>
-              <a:defRPr sz="1400"/>
+            <a:lvl2pPr marL="394746" indent="0">
+              <a:buNone/>
+              <a:defRPr sz="1209"/>
             </a:lvl2pPr>
-            <a:lvl3pPr marL="914400" indent="0">
-              <a:buNone/>
-              <a:defRPr sz="1200"/>
+            <a:lvl3pPr marL="789493" indent="0">
+              <a:buNone/>
+              <a:defRPr sz="1036"/>
             </a:lvl3pPr>
-            <a:lvl4pPr marL="1371600" indent="0">
-              <a:buNone/>
-              <a:defRPr sz="1000"/>
+            <a:lvl4pPr marL="1184239" indent="0">
+              <a:buNone/>
+              <a:defRPr sz="863"/>
             </a:lvl4pPr>
-            <a:lvl5pPr marL="1828800" indent="0">
-              <a:buNone/>
-              <a:defRPr sz="1000"/>
+            <a:lvl5pPr marL="1578986" indent="0">
+              <a:buNone/>
+              <a:defRPr sz="863"/>
             </a:lvl5pPr>
-            <a:lvl6pPr marL="2286000" indent="0">
-              <a:buNone/>
-              <a:defRPr sz="1000"/>
+            <a:lvl6pPr marL="1973732" indent="0">
+              <a:buNone/>
+              <a:defRPr sz="863"/>
             </a:lvl6pPr>
-            <a:lvl7pPr marL="2743200" indent="0">
-              <a:buNone/>
-              <a:defRPr sz="1000"/>
+            <a:lvl7pPr marL="2368479" indent="0">
+              <a:buNone/>
+              <a:defRPr sz="863"/>
             </a:lvl7pPr>
-            <a:lvl8pPr marL="3200400" indent="0">
-              <a:buNone/>
-              <a:defRPr sz="1000"/>
+            <a:lvl8pPr marL="2763225" indent="0">
+              <a:buNone/>
+              <a:defRPr sz="863"/>
             </a:lvl8pPr>
-            <a:lvl9pPr marL="3657600" indent="0">
-              <a:buNone/>
-              <a:defRPr sz="1000"/>
+            <a:lvl9pPr marL="3157972" indent="0">
+              <a:buNone/>
+              <a:defRPr sz="863"/>
             </a:lvl9pPr>
           </a:lstStyle>
           <a:p>
@@ -2388,13 +2094,7 @@
       </p:sp>
       <p:sp>
         <p:nvSpPr>
-          <p:cNvPr id="5" name="Date Placeholder 4">
-            <a:extLst>
-              <a:ext uri="{FF2B5EF4-FFF2-40B4-BE49-F238E27FC236}">
-                <a16:creationId xmlns:a16="http://schemas.microsoft.com/office/drawing/2014/main" id="{7E12E525-646D-9891-9CA3-109324A1BD35}"/>
-              </a:ext>
-            </a:extLst>
-          </p:cNvPr>
+          <p:cNvPr id="5" name="Date Placeholder 4"/>
           <p:cNvSpPr>
             <a:spLocks noGrp="1"/>
           </p:cNvSpPr>
@@ -2409,7 +2109,7 @@
           <a:p>
             <a:fld id="{918BE157-C9BD-DB4B-B849-501D8C18A188}" type="datetimeFigureOut">
               <a:rPr lang="en-US" smtClean="0"/>
-              <a:t>6/2/26</a:t>
+              <a:t>9/9/26</a:t>
             </a:fld>
             <a:endParaRPr lang="en-US"/>
           </a:p>
@@ -2417,13 +2117,7 @@
       </p:sp>
       <p:sp>
         <p:nvSpPr>
-          <p:cNvPr id="6" name="Footer Placeholder 5">
-            <a:extLst>
-              <a:ext uri="{FF2B5EF4-FFF2-40B4-BE49-F238E27FC236}">
-                <a16:creationId xmlns:a16="http://schemas.microsoft.com/office/drawing/2014/main" id="{97D8084B-82AE-AF4F-F3EF-537CC2CE76DC}"/>
-              </a:ext>
-            </a:extLst>
-          </p:cNvPr>
+          <p:cNvPr id="6" name="Footer Placeholder 5"/>
           <p:cNvSpPr>
             <a:spLocks noGrp="1"/>
           </p:cNvSpPr>
@@ -2442,13 +2136,7 @@
       </p:sp>
       <p:sp>
         <p:nvSpPr>
-          <p:cNvPr id="7" name="Slide Number Placeholder 6">
-            <a:extLst>
-              <a:ext uri="{FF2B5EF4-FFF2-40B4-BE49-F238E27FC236}">
-                <a16:creationId xmlns:a16="http://schemas.microsoft.com/office/drawing/2014/main" id="{E93B7642-F866-811F-971B-473055011BBC}"/>
-              </a:ext>
-            </a:extLst>
-          </p:cNvPr>
+          <p:cNvPr id="7" name="Slide Number Placeholder 6"/>
           <p:cNvSpPr>
             <a:spLocks noGrp="1"/>
           </p:cNvSpPr>
@@ -2472,7 +2160,7 @@
     </p:spTree>
     <p:extLst>
       <p:ext uri="{BB962C8B-B14F-4D97-AF65-F5344CB8AC3E}">
-        <p14:creationId xmlns:p14="http://schemas.microsoft.com/office/powerpoint/2010/main" val="3070782836"/>
+        <p14:creationId xmlns:p14="http://schemas.microsoft.com/office/powerpoint/2010/main" val="2833985007"/>
       </p:ext>
     </p:extLst>
   </p:cSld>
@@ -2501,13 +2189,7 @@
       </p:grpSpPr>
       <p:sp>
         <p:nvSpPr>
-          <p:cNvPr id="2" name="Title 1">
-            <a:extLst>
-              <a:ext uri="{FF2B5EF4-FFF2-40B4-BE49-F238E27FC236}">
-                <a16:creationId xmlns:a16="http://schemas.microsoft.com/office/drawing/2014/main" id="{4FADD5EB-7B4B-3046-A4BD-D20AE2DA91FE}"/>
-              </a:ext>
-            </a:extLst>
-          </p:cNvPr>
+          <p:cNvPr id="2" name="Title 1"/>
           <p:cNvSpPr>
             <a:spLocks noGrp="1"/>
           </p:cNvSpPr>
@@ -2517,15 +2199,15 @@
         </p:nvSpPr>
         <p:spPr>
           <a:xfrm>
-            <a:off x="839788" y="457200"/>
-            <a:ext cx="3932237" cy="1600200"/>
+            <a:off x="619891" y="394758"/>
+            <a:ext cx="2902585" cy="1381654"/>
           </a:xfrm>
         </p:spPr>
         <p:txBody>
           <a:bodyPr anchor="b"/>
           <a:lstStyle>
             <a:lvl1pPr>
-              <a:defRPr sz="3200"/>
+              <a:defRPr sz="2763"/>
             </a:lvl1pPr>
           </a:lstStyle>
           <a:p>
@@ -2533,21 +2215,15 @@
               <a:rPr lang="en-GB"/>
               <a:t>Click to edit Master title style</a:t>
             </a:r>
-            <a:endParaRPr lang="en-US"/>
-          </a:p>
-        </p:txBody>
-      </p:sp>
-      <p:sp>
-        <p:nvSpPr>
-          <p:cNvPr id="3" name="Picture Placeholder 2">
-            <a:extLst>
-              <a:ext uri="{FF2B5EF4-FFF2-40B4-BE49-F238E27FC236}">
-                <a16:creationId xmlns:a16="http://schemas.microsoft.com/office/drawing/2014/main" id="{E02BF07B-1B6B-E9FA-E879-558A1004E24F}"/>
-              </a:ext>
-            </a:extLst>
-          </p:cNvPr>
-          <p:cNvSpPr>
-            <a:spLocks noGrp="1"/>
+            <a:endParaRPr lang="en-US" dirty="0"/>
+          </a:p>
+        </p:txBody>
+      </p:sp>
+      <p:sp>
+        <p:nvSpPr>
+          <p:cNvPr id="3" name="Picture Placeholder 2"/>
+          <p:cNvSpPr>
+            <a:spLocks noGrp="1" noChangeAspect="1"/>
           </p:cNvSpPr>
           <p:nvPr>
             <p:ph type="pic" idx="1"/>
@@ -2555,8 +2231,73 @@
         </p:nvSpPr>
         <p:spPr>
           <a:xfrm>
-            <a:off x="5183188" y="987425"/>
-            <a:ext cx="6172200" cy="4873625"/>
+            <a:off x="3825976" y="852570"/>
+            <a:ext cx="4556016" cy="4208014"/>
+          </a:xfrm>
+        </p:spPr>
+        <p:txBody>
+          <a:bodyPr anchor="t"/>
+          <a:lstStyle>
+            <a:lvl1pPr marL="0" indent="0">
+              <a:buNone/>
+              <a:defRPr sz="2763"/>
+            </a:lvl1pPr>
+            <a:lvl2pPr marL="394746" indent="0">
+              <a:buNone/>
+              <a:defRPr sz="2418"/>
+            </a:lvl2pPr>
+            <a:lvl3pPr marL="789493" indent="0">
+              <a:buNone/>
+              <a:defRPr sz="2072"/>
+            </a:lvl3pPr>
+            <a:lvl4pPr marL="1184239" indent="0">
+              <a:buNone/>
+              <a:defRPr sz="1727"/>
+            </a:lvl4pPr>
+            <a:lvl5pPr marL="1578986" indent="0">
+              <a:buNone/>
+              <a:defRPr sz="1727"/>
+            </a:lvl5pPr>
+            <a:lvl6pPr marL="1973732" indent="0">
+              <a:buNone/>
+              <a:defRPr sz="1727"/>
+            </a:lvl6pPr>
+            <a:lvl7pPr marL="2368479" indent="0">
+              <a:buNone/>
+              <a:defRPr sz="1727"/>
+            </a:lvl7pPr>
+            <a:lvl8pPr marL="2763225" indent="0">
+              <a:buNone/>
+              <a:defRPr sz="1727"/>
+            </a:lvl8pPr>
+            <a:lvl9pPr marL="3157972" indent="0">
+              <a:buNone/>
+              <a:defRPr sz="1727"/>
+            </a:lvl9pPr>
+          </a:lstStyle>
+          <a:p>
+            <a:r>
+              <a:rPr lang="en-GB"/>
+              <a:t>Click icon to add picture</a:t>
+            </a:r>
+            <a:endParaRPr lang="en-US" dirty="0"/>
+          </a:p>
+        </p:txBody>
+      </p:sp>
+      <p:sp>
+        <p:nvSpPr>
+          <p:cNvPr id="4" name="Text Placeholder 3"/>
+          <p:cNvSpPr>
+            <a:spLocks noGrp="1"/>
+          </p:cNvSpPr>
+          <p:nvPr>
+            <p:ph type="body" sz="half" idx="2"/>
+          </p:nvPr>
+        </p:nvSpPr>
+        <p:spPr>
+          <a:xfrm>
+            <a:off x="619891" y="1776412"/>
+            <a:ext cx="2902585" cy="3291024"/>
           </a:xfrm>
         </p:spPr>
         <p:txBody>
@@ -2564,109 +2305,42 @@
           <a:lstStyle>
             <a:lvl1pPr marL="0" indent="0">
               <a:buNone/>
-              <a:defRPr sz="3200"/>
+              <a:defRPr sz="1381"/>
             </a:lvl1pPr>
-            <a:lvl2pPr marL="457200" indent="0">
-              <a:buNone/>
-              <a:defRPr sz="2800"/>
+            <a:lvl2pPr marL="394746" indent="0">
+              <a:buNone/>
+              <a:defRPr sz="1209"/>
             </a:lvl2pPr>
-            <a:lvl3pPr marL="914400" indent="0">
-              <a:buNone/>
-              <a:defRPr sz="2400"/>
+            <a:lvl3pPr marL="789493" indent="0">
+              <a:buNone/>
+              <a:defRPr sz="1036"/>
             </a:lvl3pPr>
-            <a:lvl4pPr marL="1371600" indent="0">
-              <a:buNone/>
-              <a:defRPr sz="2000"/>
+            <a:lvl4pPr marL="1184239" indent="0">
+              <a:buNone/>
+              <a:defRPr sz="863"/>
             </a:lvl4pPr>
-            <a:lvl5pPr marL="1828800" indent="0">
-              <a:buNone/>
-              <a:defRPr sz="2000"/>
+            <a:lvl5pPr marL="1578986" indent="0">
+              <a:buNone/>
+              <a:defRPr sz="863"/>
             </a:lvl5pPr>
-            <a:lvl6pPr marL="2286000" indent="0">
-              <a:buNone/>
-              <a:defRPr sz="2000"/>
+            <a:lvl6pPr marL="1973732" indent="0">
+              <a:buNone/>
+              <a:defRPr sz="863"/>
             </a:lvl6pPr>
-            <a:lvl7pPr marL="2743200" indent="0">
-              <a:buNone/>
-              <a:defRPr sz="2000"/>
+            <a:lvl7pPr marL="2368479" indent="0">
+              <a:buNone/>
+              <a:defRPr sz="863"/>
             </a:lvl7pPr>
-            <a:lvl8pPr marL="3200400" indent="0">
-              <a:buNone/>
-              <a:defRPr sz="2000"/>
+            <a:lvl8pPr marL="2763225" indent="0">
+              <a:buNone/>
+              <a:defRPr sz="863"/>
             </a:lvl8pPr>
-            <a:lvl9pPr marL="3657600" indent="0">
-              <a:buNone/>
-              <a:defRPr sz="2000"/>
+            <a:lvl9pPr marL="3157972" indent="0">
+              <a:buNone/>
+              <a:defRPr sz="863"/>
             </a:lvl9pPr>
           </a:lstStyle>
           <a:p>
-            <a:endParaRPr lang="en-US"/>
-          </a:p>
-        </p:txBody>
-      </p:sp>
-      <p:sp>
-        <p:nvSpPr>
-          <p:cNvPr id="4" name="Text Placeholder 3">
-            <a:extLst>
-              <a:ext uri="{FF2B5EF4-FFF2-40B4-BE49-F238E27FC236}">
-                <a16:creationId xmlns:a16="http://schemas.microsoft.com/office/drawing/2014/main" id="{DA531463-61E1-2815-0943-1421628C790A}"/>
-              </a:ext>
-            </a:extLst>
-          </p:cNvPr>
-          <p:cNvSpPr>
-            <a:spLocks noGrp="1"/>
-          </p:cNvSpPr>
-          <p:nvPr>
-            <p:ph type="body" sz="half" idx="2"/>
-          </p:nvPr>
-        </p:nvSpPr>
-        <p:spPr>
-          <a:xfrm>
-            <a:off x="839788" y="2057400"/>
-            <a:ext cx="3932237" cy="3811588"/>
-          </a:xfrm>
-        </p:spPr>
-        <p:txBody>
-          <a:bodyPr/>
-          <a:lstStyle>
-            <a:lvl1pPr marL="0" indent="0">
-              <a:buNone/>
-              <a:defRPr sz="1600"/>
-            </a:lvl1pPr>
-            <a:lvl2pPr marL="457200" indent="0">
-              <a:buNone/>
-              <a:defRPr sz="1400"/>
-            </a:lvl2pPr>
-            <a:lvl3pPr marL="914400" indent="0">
-              <a:buNone/>
-              <a:defRPr sz="1200"/>
-            </a:lvl3pPr>
-            <a:lvl4pPr marL="1371600" indent="0">
-              <a:buNone/>
-              <a:defRPr sz="1000"/>
-            </a:lvl4pPr>
-            <a:lvl5pPr marL="1828800" indent="0">
-              <a:buNone/>
-              <a:defRPr sz="1000"/>
-            </a:lvl5pPr>
-            <a:lvl6pPr marL="2286000" indent="0">
-              <a:buNone/>
-              <a:defRPr sz="1000"/>
-            </a:lvl6pPr>
-            <a:lvl7pPr marL="2743200" indent="0">
-              <a:buNone/>
-              <a:defRPr sz="1000"/>
-            </a:lvl7pPr>
-            <a:lvl8pPr marL="3200400" indent="0">
-              <a:buNone/>
-              <a:defRPr sz="1000"/>
-            </a:lvl8pPr>
-            <a:lvl9pPr marL="3657600" indent="0">
-              <a:buNone/>
-              <a:defRPr sz="1000"/>
-            </a:lvl9pPr>
-          </a:lstStyle>
-          <a:p>
             <a:pPr lvl="0"/>
             <a:r>
               <a:rPr lang="en-GB"/>
@@ -2677,13 +2351,7 @@
       </p:sp>
       <p:sp>
         <p:nvSpPr>
-          <p:cNvPr id="5" name="Date Placeholder 4">
-            <a:extLst>
-              <a:ext uri="{FF2B5EF4-FFF2-40B4-BE49-F238E27FC236}">
-                <a16:creationId xmlns:a16="http://schemas.microsoft.com/office/drawing/2014/main" id="{F0177808-4110-CBA3-FB5C-61FB5400F563}"/>
-              </a:ext>
-            </a:extLst>
-          </p:cNvPr>
+          <p:cNvPr id="5" name="Date Placeholder 4"/>
           <p:cNvSpPr>
             <a:spLocks noGrp="1"/>
           </p:cNvSpPr>
@@ -2698,7 +2366,7 @@
           <a:p>
             <a:fld id="{918BE157-C9BD-DB4B-B849-501D8C18A188}" type="datetimeFigureOut">
               <a:rPr lang="en-US" smtClean="0"/>
-              <a:t>6/2/26</a:t>
+              <a:t>9/9/26</a:t>
             </a:fld>
             <a:endParaRPr lang="en-US"/>
           </a:p>
@@ -2706,13 +2374,7 @@
       </p:sp>
       <p:sp>
         <p:nvSpPr>
-          <p:cNvPr id="6" name="Footer Placeholder 5">
-            <a:extLst>
-              <a:ext uri="{FF2B5EF4-FFF2-40B4-BE49-F238E27FC236}">
-                <a16:creationId xmlns:a16="http://schemas.microsoft.com/office/drawing/2014/main" id="{3948F26E-88D0-4FFE-DFFB-5E0F322ED73D}"/>
-              </a:ext>
-            </a:extLst>
-          </p:cNvPr>
+          <p:cNvPr id="6" name="Footer Placeholder 5"/>
           <p:cNvSpPr>
             <a:spLocks noGrp="1"/>
           </p:cNvSpPr>
@@ -2731,13 +2393,7 @@
       </p:sp>
       <p:sp>
         <p:nvSpPr>
-          <p:cNvPr id="7" name="Slide Number Placeholder 6">
-            <a:extLst>
-              <a:ext uri="{FF2B5EF4-FFF2-40B4-BE49-F238E27FC236}">
-                <a16:creationId xmlns:a16="http://schemas.microsoft.com/office/drawing/2014/main" id="{2912839A-DE29-5778-DD1C-80DE4319BFB1}"/>
-              </a:ext>
-            </a:extLst>
-          </p:cNvPr>
+          <p:cNvPr id="7" name="Slide Number Placeholder 6"/>
           <p:cNvSpPr>
             <a:spLocks noGrp="1"/>
           </p:cNvSpPr>
@@ -2761,7 +2417,7 @@
     </p:spTree>
     <p:extLst>
       <p:ext uri="{BB962C8B-B14F-4D97-AF65-F5344CB8AC3E}">
-        <p14:creationId xmlns:p14="http://schemas.microsoft.com/office/powerpoint/2010/main" val="2476886236"/>
+        <p14:creationId xmlns:p14="http://schemas.microsoft.com/office/powerpoint/2010/main" val="2104713913"/>
       </p:ext>
     </p:extLst>
   </p:cSld>
@@ -2795,13 +2451,7 @@
       </p:grpSpPr>
       <p:sp>
         <p:nvSpPr>
-          <p:cNvPr id="2" name="Title Placeholder 1">
-            <a:extLst>
-              <a:ext uri="{FF2B5EF4-FFF2-40B4-BE49-F238E27FC236}">
-                <a16:creationId xmlns:a16="http://schemas.microsoft.com/office/drawing/2014/main" id="{AEA1E3E6-6003-6E57-E09D-2D5DDA096DD4}"/>
-              </a:ext>
-            </a:extLst>
-          </p:cNvPr>
+          <p:cNvPr id="2" name="Title Placeholder 1"/>
           <p:cNvSpPr>
             <a:spLocks noGrp="1"/>
           </p:cNvSpPr>
@@ -2811,8 +2461,8 @@
         </p:nvSpPr>
         <p:spPr>
           <a:xfrm>
-            <a:off x="838200" y="365125"/>
-            <a:ext cx="10515600" cy="1325563"/>
+            <a:off x="618718" y="315260"/>
+            <a:ext cx="7762102" cy="1144525"/>
           </a:xfrm>
           <a:prstGeom prst="rect">
             <a:avLst/>
@@ -2828,19 +2478,13 @@
               <a:rPr lang="en-GB"/>
               <a:t>Click to edit Master title style</a:t>
             </a:r>
-            <a:endParaRPr lang="en-US"/>
-          </a:p>
-        </p:txBody>
-      </p:sp>
-      <p:sp>
-        <p:nvSpPr>
-          <p:cNvPr id="3" name="Text Placeholder 2">
-            <a:extLst>
-              <a:ext uri="{FF2B5EF4-FFF2-40B4-BE49-F238E27FC236}">
-                <a16:creationId xmlns:a16="http://schemas.microsoft.com/office/drawing/2014/main" id="{943D7EF2-A518-8CE9-30F2-5191412BA63E}"/>
-              </a:ext>
-            </a:extLst>
-          </p:cNvPr>
+            <a:endParaRPr lang="en-US" dirty="0"/>
+          </a:p>
+        </p:txBody>
+      </p:sp>
+      <p:sp>
+        <p:nvSpPr>
+          <p:cNvPr id="3" name="Text Placeholder 2"/>
           <p:cNvSpPr>
             <a:spLocks noGrp="1"/>
           </p:cNvSpPr>
@@ -2850,8 +2494,8 @@
         </p:nvSpPr>
         <p:spPr>
           <a:xfrm>
-            <a:off x="838200" y="1825625"/>
-            <a:ext cx="10515600" cy="4351338"/>
+            <a:off x="618718" y="1576292"/>
+            <a:ext cx="7762102" cy="3757058"/>
           </a:xfrm>
           <a:prstGeom prst="rect">
             <a:avLst/>
@@ -2896,19 +2540,13 @@
               <a:rPr lang="en-GB"/>
               <a:t>Fifth level</a:t>
             </a:r>
-            <a:endParaRPr lang="en-US"/>
-          </a:p>
-        </p:txBody>
-      </p:sp>
-      <p:sp>
-        <p:nvSpPr>
-          <p:cNvPr id="4" name="Date Placeholder 3">
-            <a:extLst>
-              <a:ext uri="{FF2B5EF4-FFF2-40B4-BE49-F238E27FC236}">
-                <a16:creationId xmlns:a16="http://schemas.microsoft.com/office/drawing/2014/main" id="{8375B700-5556-892A-519D-C370FF23B560}"/>
-              </a:ext>
-            </a:extLst>
-          </p:cNvPr>
+            <a:endParaRPr lang="en-US" dirty="0"/>
+          </a:p>
+        </p:txBody>
+      </p:sp>
+      <p:sp>
+        <p:nvSpPr>
+          <p:cNvPr id="4" name="Date Placeholder 3"/>
           <p:cNvSpPr>
             <a:spLocks noGrp="1"/>
           </p:cNvSpPr>
@@ -2918,8 +2556,8 @@
         </p:nvSpPr>
         <p:spPr>
           <a:xfrm>
-            <a:off x="838200" y="6356350"/>
-            <a:ext cx="2743200" cy="365125"/>
+            <a:off x="618718" y="5488239"/>
+            <a:ext cx="2024896" cy="315258"/>
           </a:xfrm>
           <a:prstGeom prst="rect">
             <a:avLst/>
@@ -2929,7 +2567,7 @@
           <a:bodyPr vert="horz" lIns="91440" tIns="45720" rIns="91440" bIns="45720" rtlCol="0" anchor="ctr"/>
           <a:lstStyle>
             <a:lvl1pPr algn="l">
-              <a:defRPr sz="1200">
+              <a:defRPr sz="1036">
                 <a:solidFill>
                   <a:schemeClr val="tx1">
                     <a:tint val="82000"/>
@@ -2941,7 +2579,7 @@
           <a:p>
             <a:fld id="{918BE157-C9BD-DB4B-B849-501D8C18A188}" type="datetimeFigureOut">
               <a:rPr lang="en-US" smtClean="0"/>
-              <a:t>6/2/26</a:t>
+              <a:t>9/9/26</a:t>
             </a:fld>
             <a:endParaRPr lang="en-US"/>
           </a:p>
@@ -2949,13 +2587,7 @@
       </p:sp>
       <p:sp>
         <p:nvSpPr>
-          <p:cNvPr id="5" name="Footer Placeholder 4">
-            <a:extLst>
-              <a:ext uri="{FF2B5EF4-FFF2-40B4-BE49-F238E27FC236}">
-                <a16:creationId xmlns:a16="http://schemas.microsoft.com/office/drawing/2014/main" id="{2F062028-06A3-EBBA-2620-8C9891808773}"/>
-              </a:ext>
-            </a:extLst>
-          </p:cNvPr>
+          <p:cNvPr id="5" name="Footer Placeholder 4"/>
           <p:cNvSpPr>
             <a:spLocks noGrp="1"/>
           </p:cNvSpPr>
@@ -2965,8 +2597,8 @@
         </p:nvSpPr>
         <p:spPr>
           <a:xfrm>
-            <a:off x="4038600" y="6356350"/>
-            <a:ext cx="4114800" cy="365125"/>
+            <a:off x="2981097" y="5488239"/>
+            <a:ext cx="3037344" cy="315258"/>
           </a:xfrm>
           <a:prstGeom prst="rect">
             <a:avLst/>
@@ -2976,7 +2608,7 @@
           <a:bodyPr vert="horz" lIns="91440" tIns="45720" rIns="91440" bIns="45720" rtlCol="0" anchor="ctr"/>
           <a:lstStyle>
             <a:lvl1pPr algn="ctr">
-              <a:defRPr sz="1200">
+              <a:defRPr sz="1036">
                 <a:solidFill>
                   <a:schemeClr val="tx1">
                     <a:tint val="82000"/>
@@ -2992,13 +2624,7 @@
       </p:sp>
       <p:sp>
         <p:nvSpPr>
-          <p:cNvPr id="6" name="Slide Number Placeholder 5">
-            <a:extLst>
-              <a:ext uri="{FF2B5EF4-FFF2-40B4-BE49-F238E27FC236}">
-                <a16:creationId xmlns:a16="http://schemas.microsoft.com/office/drawing/2014/main" id="{82C8C351-D6DA-BE7E-0299-F6CCE109FD71}"/>
-              </a:ext>
-            </a:extLst>
-          </p:cNvPr>
+          <p:cNvPr id="6" name="Slide Number Placeholder 5"/>
           <p:cNvSpPr>
             <a:spLocks noGrp="1"/>
           </p:cNvSpPr>
@@ -3008,8 +2634,8 @@
         </p:nvSpPr>
         <p:spPr>
           <a:xfrm>
-            <a:off x="8610600" y="6356350"/>
-            <a:ext cx="2743200" cy="365125"/>
+            <a:off x="6355924" y="5488239"/>
+            <a:ext cx="2024896" cy="315258"/>
           </a:xfrm>
           <a:prstGeom prst="rect">
             <a:avLst/>
@@ -3019,7 +2645,7 @@
           <a:bodyPr vert="horz" lIns="91440" tIns="45720" rIns="91440" bIns="45720" rtlCol="0" anchor="ctr"/>
           <a:lstStyle>
             <a:lvl1pPr algn="r">
-              <a:defRPr sz="1200">
+              <a:defRPr sz="1036">
                 <a:solidFill>
                   <a:schemeClr val="tx1">
                     <a:tint val="82000"/>
@@ -3040,27 +2666,27 @@
     </p:spTree>
     <p:extLst>
       <p:ext uri="{BB962C8B-B14F-4D97-AF65-F5344CB8AC3E}">
-        <p14:creationId xmlns:p14="http://schemas.microsoft.com/office/powerpoint/2010/main" val="3812523339"/>
+        <p14:creationId xmlns:p14="http://schemas.microsoft.com/office/powerpoint/2010/main" val="2906813202"/>
       </p:ext>
     </p:extLst>
   </p:cSld>
   <p:clrMap bg1="lt1" tx1="dk1" bg2="lt2" tx2="dk2" accent1="accent1" accent2="accent2" accent3="accent3" accent4="accent4" accent5="accent5" accent6="accent6" hlink="hlink" folHlink="folHlink"/>
   <p:sldLayoutIdLst>
-    <p:sldLayoutId id="2147483649" r:id="rId1"/>
-    <p:sldLayoutId id="2147483650" r:id="rId2"/>
-    <p:sldLayoutId id="2147483651" r:id="rId3"/>
-    <p:sldLayoutId id="2147483652" r:id="rId4"/>
-    <p:sldLayoutId id="2147483653" r:id="rId5"/>
-    <p:sldLayoutId id="2147483654" r:id="rId6"/>
-    <p:sldLayoutId id="2147483655" r:id="rId7"/>
-    <p:sldLayoutId id="2147483656" r:id="rId8"/>
-    <p:sldLayoutId id="2147483657" r:id="rId9"/>
-    <p:sldLayoutId id="2147483658" r:id="rId10"/>
-    <p:sldLayoutId id="2147483659" r:id="rId11"/>
+    <p:sldLayoutId id="2147483673" r:id="rId1"/>
+    <p:sldLayoutId id="2147483674" r:id="rId2"/>
+    <p:sldLayoutId id="2147483675" r:id="rId3"/>
+    <p:sldLayoutId id="2147483676" r:id="rId4"/>
+    <p:sldLayoutId id="2147483677" r:id="rId5"/>
+    <p:sldLayoutId id="2147483678" r:id="rId6"/>
+    <p:sldLayoutId id="2147483679" r:id="rId7"/>
+    <p:sldLayoutId id="2147483680" r:id="rId8"/>
+    <p:sldLayoutId id="2147483681" r:id="rId9"/>
+    <p:sldLayoutId id="2147483682" r:id="rId10"/>
+    <p:sldLayoutId id="2147483683" r:id="rId11"/>
   </p:sldLayoutIdLst>
   <p:txStyles>
     <p:titleStyle>
-      <a:lvl1pPr algn="l" defTabSz="914400" rtl="0" eaLnBrk="1" latinLnBrk="0" hangingPunct="1">
+      <a:lvl1pPr algn="l" defTabSz="789493" rtl="0" eaLnBrk="1" latinLnBrk="0" hangingPunct="1">
         <a:lnSpc>
           <a:spcPct val="90000"/>
         </a:lnSpc>
@@ -3068,7 +2694,7 @@
           <a:spcPct val="0"/>
         </a:spcBef>
         <a:buNone/>
-        <a:defRPr sz="4400" kern="1200">
+        <a:defRPr sz="3799" kern="1200">
           <a:solidFill>
             <a:schemeClr val="tx1"/>
           </a:solidFill>
@@ -3079,16 +2705,16 @@
       </a:lvl1pPr>
     </p:titleStyle>
     <p:bodyStyle>
-      <a:lvl1pPr marL="228600" indent="-228600" algn="l" defTabSz="914400" rtl="0" eaLnBrk="1" latinLnBrk="0" hangingPunct="1">
+      <a:lvl1pPr marL="197373" indent="-197373" algn="l" defTabSz="789493" rtl="0" eaLnBrk="1" latinLnBrk="0" hangingPunct="1">
         <a:lnSpc>
           <a:spcPct val="90000"/>
         </a:lnSpc>
         <a:spcBef>
-          <a:spcPts val="1000"/>
+          <a:spcPts val="863"/>
         </a:spcBef>
         <a:buFont typeface="Arial" panose="020B0604020202020204" pitchFamily="34" charset="0"/>
         <a:buChar char="•"/>
-        <a:defRPr sz="2800" kern="1200">
+        <a:defRPr sz="2418" kern="1200">
           <a:solidFill>
             <a:schemeClr val="tx1"/>
           </a:solidFill>
@@ -3097,16 +2723,16 @@
           <a:cs typeface="+mn-cs"/>
         </a:defRPr>
       </a:lvl1pPr>
-      <a:lvl2pPr marL="685800" indent="-228600" algn="l" defTabSz="914400" rtl="0" eaLnBrk="1" latinLnBrk="0" hangingPunct="1">
+      <a:lvl2pPr marL="592120" indent="-197373" algn="l" defTabSz="789493" rtl="0" eaLnBrk="1" latinLnBrk="0" hangingPunct="1">
         <a:lnSpc>
           <a:spcPct val="90000"/>
         </a:lnSpc>
         <a:spcBef>
-          <a:spcPts val="500"/>
+          <a:spcPts val="432"/>
         </a:spcBef>
         <a:buFont typeface="Arial" panose="020B0604020202020204" pitchFamily="34" charset="0"/>
         <a:buChar char="•"/>
-        <a:defRPr sz="2400" kern="1200">
+        <a:defRPr sz="2072" kern="1200">
           <a:solidFill>
             <a:schemeClr val="tx1"/>
           </a:solidFill>
@@ -3115,16 +2741,16 @@
           <a:cs typeface="+mn-cs"/>
         </a:defRPr>
       </a:lvl2pPr>
-      <a:lvl3pPr marL="1143000" indent="-228600" algn="l" defTabSz="914400" rtl="0" eaLnBrk="1" latinLnBrk="0" hangingPunct="1">
+      <a:lvl3pPr marL="986866" indent="-197373" algn="l" defTabSz="789493" rtl="0" eaLnBrk="1" latinLnBrk="0" hangingPunct="1">
         <a:lnSpc>
           <a:spcPct val="90000"/>
         </a:lnSpc>
         <a:spcBef>
-          <a:spcPts val="500"/>
+          <a:spcPts val="432"/>
         </a:spcBef>
         <a:buFont typeface="Arial" panose="020B0604020202020204" pitchFamily="34" charset="0"/>
         <a:buChar char="•"/>
-        <a:defRPr sz="2000" kern="1200">
+        <a:defRPr sz="1727" kern="1200">
           <a:solidFill>
             <a:schemeClr val="tx1"/>
           </a:solidFill>
@@ -3133,16 +2759,16 @@
           <a:cs typeface="+mn-cs"/>
         </a:defRPr>
       </a:lvl3pPr>
-      <a:lvl4pPr marL="1600200" indent="-228600" algn="l" defTabSz="914400" rtl="0" eaLnBrk="1" latinLnBrk="0" hangingPunct="1">
+      <a:lvl4pPr marL="1381613" indent="-197373" algn="l" defTabSz="789493" rtl="0" eaLnBrk="1" latinLnBrk="0" hangingPunct="1">
         <a:lnSpc>
           <a:spcPct val="90000"/>
         </a:lnSpc>
         <a:spcBef>
-          <a:spcPts val="500"/>
+          <a:spcPts val="432"/>
         </a:spcBef>
         <a:buFont typeface="Arial" panose="020B0604020202020204" pitchFamily="34" charset="0"/>
         <a:buChar char="•"/>
-        <a:defRPr sz="1800" kern="1200">
+        <a:defRPr sz="1554" kern="1200">
           <a:solidFill>
             <a:schemeClr val="tx1"/>
           </a:solidFill>
@@ -3151,16 +2777,16 @@
           <a:cs typeface="+mn-cs"/>
         </a:defRPr>
       </a:lvl4pPr>
-      <a:lvl5pPr marL="2057400" indent="-228600" algn="l" defTabSz="914400" rtl="0" eaLnBrk="1" latinLnBrk="0" hangingPunct="1">
+      <a:lvl5pPr marL="1776359" indent="-197373" algn="l" defTabSz="789493" rtl="0" eaLnBrk="1" latinLnBrk="0" hangingPunct="1">
         <a:lnSpc>
           <a:spcPct val="90000"/>
         </a:lnSpc>
         <a:spcBef>
-          <a:spcPts val="500"/>
+          <a:spcPts val="432"/>
         </a:spcBef>
         <a:buFont typeface="Arial" panose="020B0604020202020204" pitchFamily="34" charset="0"/>
         <a:buChar char="•"/>
-        <a:defRPr sz="1800" kern="1200">
+        <a:defRPr sz="1554" kern="1200">
           <a:solidFill>
             <a:schemeClr val="tx1"/>
           </a:solidFill>
@@ -3169,16 +2795,16 @@
           <a:cs typeface="+mn-cs"/>
         </a:defRPr>
       </a:lvl5pPr>
-      <a:lvl6pPr marL="2514600" indent="-228600" algn="l" defTabSz="914400" rtl="0" eaLnBrk="1" latinLnBrk="0" hangingPunct="1">
+      <a:lvl6pPr marL="2171106" indent="-197373" algn="l" defTabSz="789493" rtl="0" eaLnBrk="1" latinLnBrk="0" hangingPunct="1">
         <a:lnSpc>
           <a:spcPct val="90000"/>
         </a:lnSpc>
         <a:spcBef>
-          <a:spcPts val="500"/>
+          <a:spcPts val="432"/>
         </a:spcBef>
         <a:buFont typeface="Arial" panose="020B0604020202020204" pitchFamily="34" charset="0"/>
         <a:buChar char="•"/>
-        <a:defRPr sz="1800" kern="1200">
+        <a:defRPr sz="1554" kern="1200">
           <a:solidFill>
             <a:schemeClr val="tx1"/>
           </a:solidFill>
@@ -3187,16 +2813,16 @@
           <a:cs typeface="+mn-cs"/>
         </a:defRPr>
       </a:lvl6pPr>
-      <a:lvl7pPr marL="2971800" indent="-228600" algn="l" defTabSz="914400" rtl="0" eaLnBrk="1" latinLnBrk="0" hangingPunct="1">
+      <a:lvl7pPr marL="2565852" indent="-197373" algn="l" defTabSz="789493" rtl="0" eaLnBrk="1" latinLnBrk="0" hangingPunct="1">
         <a:lnSpc>
           <a:spcPct val="90000"/>
         </a:lnSpc>
         <a:spcBef>
-          <a:spcPts val="500"/>
+          <a:spcPts val="432"/>
         </a:spcBef>
         <a:buFont typeface="Arial" panose="020B0604020202020204" pitchFamily="34" charset="0"/>
         <a:buChar char="•"/>
-        <a:defRPr sz="1800" kern="1200">
+        <a:defRPr sz="1554" kern="1200">
           <a:solidFill>
             <a:schemeClr val="tx1"/>
           </a:solidFill>
@@ -3205,16 +2831,16 @@
           <a:cs typeface="+mn-cs"/>
         </a:defRPr>
       </a:lvl7pPr>
-      <a:lvl8pPr marL="3429000" indent="-228600" algn="l" defTabSz="914400" rtl="0" eaLnBrk="1" latinLnBrk="0" hangingPunct="1">
+      <a:lvl8pPr marL="2960599" indent="-197373" algn="l" defTabSz="789493" rtl="0" eaLnBrk="1" latinLnBrk="0" hangingPunct="1">
         <a:lnSpc>
           <a:spcPct val="90000"/>
         </a:lnSpc>
         <a:spcBef>
-          <a:spcPts val="500"/>
+          <a:spcPts val="432"/>
         </a:spcBef>
         <a:buFont typeface="Arial" panose="020B0604020202020204" pitchFamily="34" charset="0"/>
         <a:buChar char="•"/>
-        <a:defRPr sz="1800" kern="1200">
+        <a:defRPr sz="1554" kern="1200">
           <a:solidFill>
             <a:schemeClr val="tx1"/>
           </a:solidFill>
@@ -3223,16 +2849,16 @@
           <a:cs typeface="+mn-cs"/>
         </a:defRPr>
       </a:lvl8pPr>
-      <a:lvl9pPr marL="3886200" indent="-228600" algn="l" defTabSz="914400" rtl="0" eaLnBrk="1" latinLnBrk="0" hangingPunct="1">
+      <a:lvl9pPr marL="3355345" indent="-197373" algn="l" defTabSz="789493" rtl="0" eaLnBrk="1" latinLnBrk="0" hangingPunct="1">
         <a:lnSpc>
           <a:spcPct val="90000"/>
         </a:lnSpc>
         <a:spcBef>
-          <a:spcPts val="500"/>
+          <a:spcPts val="432"/>
         </a:spcBef>
         <a:buFont typeface="Arial" panose="020B0604020202020204" pitchFamily="34" charset="0"/>
         <a:buChar char="•"/>
-        <a:defRPr sz="1800" kern="1200">
+        <a:defRPr sz="1554" kern="1200">
           <a:solidFill>
             <a:schemeClr val="tx1"/>
           </a:solidFill>
@@ -3246,8 +2872,8 @@
       <a:defPPr>
         <a:defRPr lang="en-US"/>
       </a:defPPr>
-      <a:lvl1pPr marL="0" algn="l" defTabSz="914400" rtl="0" eaLnBrk="1" latinLnBrk="0" hangingPunct="1">
-        <a:defRPr sz="1800" kern="1200">
+      <a:lvl1pPr marL="0" algn="l" defTabSz="789493" rtl="0" eaLnBrk="1" latinLnBrk="0" hangingPunct="1">
+        <a:defRPr sz="1554" kern="1200">
           <a:solidFill>
             <a:schemeClr val="tx1"/>
           </a:solidFill>
@@ -3256,8 +2882,8 @@
           <a:cs typeface="+mn-cs"/>
         </a:defRPr>
       </a:lvl1pPr>
-      <a:lvl2pPr marL="457200" algn="l" defTabSz="914400" rtl="0" eaLnBrk="1" latinLnBrk="0" hangingPunct="1">
-        <a:defRPr sz="1800" kern="1200">
+      <a:lvl2pPr marL="394746" algn="l" defTabSz="789493" rtl="0" eaLnBrk="1" latinLnBrk="0" hangingPunct="1">
+        <a:defRPr sz="1554" kern="1200">
           <a:solidFill>
             <a:schemeClr val="tx1"/>
           </a:solidFill>
@@ -3266,8 +2892,8 @@
           <a:cs typeface="+mn-cs"/>
         </a:defRPr>
       </a:lvl2pPr>
-      <a:lvl3pPr marL="914400" algn="l" defTabSz="914400" rtl="0" eaLnBrk="1" latinLnBrk="0" hangingPunct="1">
-        <a:defRPr sz="1800" kern="1200">
+      <a:lvl3pPr marL="789493" algn="l" defTabSz="789493" rtl="0" eaLnBrk="1" latinLnBrk="0" hangingPunct="1">
+        <a:defRPr sz="1554" kern="1200">
           <a:solidFill>
             <a:schemeClr val="tx1"/>
           </a:solidFill>
@@ -3276,8 +2902,8 @@
           <a:cs typeface="+mn-cs"/>
         </a:defRPr>
       </a:lvl3pPr>
-      <a:lvl4pPr marL="1371600" algn="l" defTabSz="914400" rtl="0" eaLnBrk="1" latinLnBrk="0" hangingPunct="1">
-        <a:defRPr sz="1800" kern="1200">
+      <a:lvl4pPr marL="1184239" algn="l" defTabSz="789493" rtl="0" eaLnBrk="1" latinLnBrk="0" hangingPunct="1">
+        <a:defRPr sz="1554" kern="1200">
           <a:solidFill>
             <a:schemeClr val="tx1"/>
           </a:solidFill>
@@ -3286,8 +2912,8 @@
           <a:cs typeface="+mn-cs"/>
         </a:defRPr>
       </a:lvl4pPr>
-      <a:lvl5pPr marL="1828800" algn="l" defTabSz="914400" rtl="0" eaLnBrk="1" latinLnBrk="0" hangingPunct="1">
-        <a:defRPr sz="1800" kern="1200">
+      <a:lvl5pPr marL="1578986" algn="l" defTabSz="789493" rtl="0" eaLnBrk="1" latinLnBrk="0" hangingPunct="1">
+        <a:defRPr sz="1554" kern="1200">
           <a:solidFill>
             <a:schemeClr val="tx1"/>
           </a:solidFill>
@@ -3296,8 +2922,8 @@
           <a:cs typeface="+mn-cs"/>
         </a:defRPr>
       </a:lvl5pPr>
-      <a:lvl6pPr marL="2286000" algn="l" defTabSz="914400" rtl="0" eaLnBrk="1" latinLnBrk="0" hangingPunct="1">
-        <a:defRPr sz="1800" kern="1200">
+      <a:lvl6pPr marL="1973732" algn="l" defTabSz="789493" rtl="0" eaLnBrk="1" latinLnBrk="0" hangingPunct="1">
+        <a:defRPr sz="1554" kern="1200">
           <a:solidFill>
             <a:schemeClr val="tx1"/>
           </a:solidFill>
@@ -3306,8 +2932,8 @@
           <a:cs typeface="+mn-cs"/>
         </a:defRPr>
       </a:lvl6pPr>
-      <a:lvl7pPr marL="2743200" algn="l" defTabSz="914400" rtl="0" eaLnBrk="1" latinLnBrk="0" hangingPunct="1">
-        <a:defRPr sz="1800" kern="1200">
+      <a:lvl7pPr marL="2368479" algn="l" defTabSz="789493" rtl="0" eaLnBrk="1" latinLnBrk="0" hangingPunct="1">
+        <a:defRPr sz="1554" kern="1200">
           <a:solidFill>
             <a:schemeClr val="tx1"/>
           </a:solidFill>
@@ -3316,8 +2942,8 @@
           <a:cs typeface="+mn-cs"/>
         </a:defRPr>
       </a:lvl7pPr>
-      <a:lvl8pPr marL="3200400" algn="l" defTabSz="914400" rtl="0" eaLnBrk="1" latinLnBrk="0" hangingPunct="1">
-        <a:defRPr sz="1800" kern="1200">
+      <a:lvl8pPr marL="2763225" algn="l" defTabSz="789493" rtl="0" eaLnBrk="1" latinLnBrk="0" hangingPunct="1">
+        <a:defRPr sz="1554" kern="1200">
           <a:solidFill>
             <a:schemeClr val="tx1"/>
           </a:solidFill>
@@ -3326,8 +2952,8 @@
           <a:cs typeface="+mn-cs"/>
         </a:defRPr>
       </a:lvl8pPr>
-      <a:lvl9pPr marL="3657600" algn="l" defTabSz="914400" rtl="0" eaLnBrk="1" latinLnBrk="0" hangingPunct="1">
-        <a:defRPr sz="1800" kern="1200">
+      <a:lvl9pPr marL="3157972" algn="l" defTabSz="789493" rtl="0" eaLnBrk="1" latinLnBrk="0" hangingPunct="1">
+        <a:defRPr sz="1554" kern="1200">
           <a:solidFill>
             <a:schemeClr val="tx1"/>
           </a:solidFill>
@@ -3372,7 +2998,7 @@
         </p:nvGrpSpPr>
         <p:grpSpPr>
           <a:xfrm>
-            <a:off x="551384" y="-891480"/>
+            <a:off x="683347" y="-999753"/>
             <a:ext cx="3166809" cy="5171187"/>
             <a:chOff x="546233" y="-958223"/>
             <a:chExt cx="3166809" cy="5171187"/>
@@ -3816,7 +3442,7 @@
         </p:nvGrpSpPr>
         <p:grpSpPr>
           <a:xfrm>
-            <a:off x="4589754" y="1335503"/>
+            <a:off x="4721715" y="1227230"/>
             <a:ext cx="2880320" cy="720080"/>
             <a:chOff x="695400" y="1268760"/>
             <a:chExt cx="2880320" cy="720080"/>
@@ -4074,7 +3700,7 @@
         </p:nvGrpSpPr>
         <p:grpSpPr>
           <a:xfrm>
-            <a:off x="8477415" y="1335503"/>
+            <a:off x="836921" y="3601838"/>
             <a:ext cx="2880320" cy="720080"/>
             <a:chOff x="695400" y="1268760"/>
             <a:chExt cx="2880320" cy="720080"/>
@@ -4416,7 +4042,7 @@
         </p:nvGrpSpPr>
         <p:grpSpPr>
           <a:xfrm>
-            <a:off x="563230" y="1916832"/>
+            <a:off x="4578473" y="1376513"/>
             <a:ext cx="3154963" cy="3154963"/>
             <a:chOff x="558079" y="-958223"/>
             <a:chExt cx="3154963" cy="3154963"/>
@@ -4795,633 +4421,6 @@
           </p:txBody>
         </p:sp>
       </p:grpSp>
-      <p:grpSp>
-        <p:nvGrpSpPr>
-          <p:cNvPr id="105" name="Group 104">
-            <a:extLst>
-              <a:ext uri="{FF2B5EF4-FFF2-40B4-BE49-F238E27FC236}">
-                <a16:creationId xmlns:a16="http://schemas.microsoft.com/office/drawing/2014/main" id="{2A8B7B82-B0A9-D381-CDB7-D6D3A28D8745}"/>
-              </a:ext>
-            </a:extLst>
-          </p:cNvPr>
-          <p:cNvGrpSpPr/>
-          <p:nvPr/>
-        </p:nvGrpSpPr>
-        <p:grpSpPr>
-          <a:xfrm>
-            <a:off x="4440587" y="3933056"/>
-            <a:ext cx="3154963" cy="3154963"/>
-            <a:chOff x="546233" y="1058001"/>
-            <a:chExt cx="3154963" cy="3154963"/>
-          </a:xfrm>
-        </p:grpSpPr>
-        <p:sp>
-          <p:nvSpPr>
-            <p:cNvPr id="106" name="Oval 105">
-              <a:extLst>
-                <a:ext uri="{FF2B5EF4-FFF2-40B4-BE49-F238E27FC236}">
-                  <a16:creationId xmlns:a16="http://schemas.microsoft.com/office/drawing/2014/main" id="{68CFABA4-89A2-1019-143A-0322D0D299D2}"/>
-                </a:ext>
-              </a:extLst>
-            </p:cNvPr>
-            <p:cNvSpPr/>
-            <p:nvPr/>
-          </p:nvSpPr>
-          <p:spPr>
-            <a:xfrm>
-              <a:off x="695400" y="1268760"/>
-              <a:ext cx="720080" cy="720080"/>
-            </a:xfrm>
-            <a:prstGeom prst="ellipse">
-              <a:avLst/>
-            </a:prstGeom>
-            <a:solidFill>
-              <a:srgbClr val="FBE4CC"/>
-            </a:solidFill>
-          </p:spPr>
-          <p:style>
-            <a:lnRef idx="2">
-              <a:schemeClr val="accent1">
-                <a:shade val="15000"/>
-              </a:schemeClr>
-            </a:lnRef>
-            <a:fillRef idx="1">
-              <a:schemeClr val="accent1"/>
-            </a:fillRef>
-            <a:effectRef idx="0">
-              <a:schemeClr val="accent1"/>
-            </a:effectRef>
-            <a:fontRef idx="minor">
-              <a:schemeClr val="lt1"/>
-            </a:fontRef>
-          </p:style>
-          <p:txBody>
-            <a:bodyPr rtlCol="0" anchor="ctr"/>
-            <a:lstStyle/>
-            <a:p>
-              <a:pPr algn="ctr"/>
-              <a:endParaRPr lang="en-US" sz="750" dirty="0">
-                <a:latin typeface="Helvetica" pitchFamily="2" charset="0"/>
-              </a:endParaRPr>
-            </a:p>
-          </p:txBody>
-        </p:sp>
-        <p:sp>
-          <p:nvSpPr>
-            <p:cNvPr id="107" name="Oval 106">
-              <a:extLst>
-                <a:ext uri="{FF2B5EF4-FFF2-40B4-BE49-F238E27FC236}">
-                  <a16:creationId xmlns:a16="http://schemas.microsoft.com/office/drawing/2014/main" id="{C12F206A-6AA6-8031-6905-FDD05DC675E4}"/>
-                </a:ext>
-              </a:extLst>
-            </p:cNvPr>
-            <p:cNvSpPr/>
-            <p:nvPr/>
-          </p:nvSpPr>
-          <p:spPr>
-            <a:xfrm>
-              <a:off x="1775520" y="1268760"/>
-              <a:ext cx="720080" cy="720080"/>
-            </a:xfrm>
-            <a:prstGeom prst="ellipse">
-              <a:avLst/>
-            </a:prstGeom>
-            <a:solidFill>
-              <a:srgbClr val="FCAD6B"/>
-            </a:solidFill>
-          </p:spPr>
-          <p:style>
-            <a:lnRef idx="2">
-              <a:schemeClr val="accent1">
-                <a:shade val="15000"/>
-              </a:schemeClr>
-            </a:lnRef>
-            <a:fillRef idx="1">
-              <a:schemeClr val="accent1"/>
-            </a:fillRef>
-            <a:effectRef idx="0">
-              <a:schemeClr val="accent1"/>
-            </a:effectRef>
-            <a:fontRef idx="minor">
-              <a:schemeClr val="lt1"/>
-            </a:fontRef>
-          </p:style>
-          <p:txBody>
-            <a:bodyPr rtlCol="0" anchor="ctr"/>
-            <a:lstStyle/>
-            <a:p>
-              <a:pPr algn="ctr"/>
-              <a:endParaRPr lang="en-US" sz="750" dirty="0">
-                <a:latin typeface="Helvetica" pitchFamily="2" charset="0"/>
-              </a:endParaRPr>
-            </a:p>
-          </p:txBody>
-        </p:sp>
-        <p:sp>
-          <p:nvSpPr>
-            <p:cNvPr id="108" name="Oval 107">
-              <a:extLst>
-                <a:ext uri="{FF2B5EF4-FFF2-40B4-BE49-F238E27FC236}">
-                  <a16:creationId xmlns:a16="http://schemas.microsoft.com/office/drawing/2014/main" id="{B5B0B4CA-CD4F-F6F8-6519-E795347FF8E8}"/>
-                </a:ext>
-              </a:extLst>
-            </p:cNvPr>
-            <p:cNvSpPr/>
-            <p:nvPr/>
-          </p:nvSpPr>
-          <p:spPr>
-            <a:xfrm>
-              <a:off x="2855640" y="1268760"/>
-              <a:ext cx="720080" cy="720080"/>
-            </a:xfrm>
-            <a:prstGeom prst="ellipse">
-              <a:avLst/>
-            </a:prstGeom>
-            <a:solidFill>
-              <a:srgbClr val="E6550E"/>
-            </a:solidFill>
-          </p:spPr>
-          <p:style>
-            <a:lnRef idx="2">
-              <a:schemeClr val="accent1">
-                <a:shade val="15000"/>
-              </a:schemeClr>
-            </a:lnRef>
-            <a:fillRef idx="1">
-              <a:schemeClr val="accent1"/>
-            </a:fillRef>
-            <a:effectRef idx="0">
-              <a:schemeClr val="accent1"/>
-            </a:effectRef>
-            <a:fontRef idx="minor">
-              <a:schemeClr val="lt1"/>
-            </a:fontRef>
-          </p:style>
-          <p:txBody>
-            <a:bodyPr rtlCol="0" anchor="ctr"/>
-            <a:lstStyle/>
-            <a:p>
-              <a:pPr algn="ctr"/>
-              <a:endParaRPr lang="en-US" sz="750" dirty="0">
-                <a:latin typeface="Helvetica" pitchFamily="2" charset="0"/>
-              </a:endParaRPr>
-            </a:p>
-          </p:txBody>
-        </p:sp>
-        <p:cxnSp>
-          <p:nvCxnSpPr>
-            <p:cNvPr id="109" name="Straight Arrow Connector 108">
-              <a:extLst>
-                <a:ext uri="{FF2B5EF4-FFF2-40B4-BE49-F238E27FC236}">
-                  <a16:creationId xmlns:a16="http://schemas.microsoft.com/office/drawing/2014/main" id="{02729AC7-CCFD-8F05-315C-7338BF4975C7}"/>
-                </a:ext>
-              </a:extLst>
-            </p:cNvPr>
-            <p:cNvCxnSpPr>
-              <a:cxnSpLocks/>
-            </p:cNvCxnSpPr>
-            <p:nvPr/>
-          </p:nvCxnSpPr>
-          <p:spPr>
-            <a:xfrm>
-              <a:off x="1432100" y="1634065"/>
-              <a:ext cx="343420" cy="0"/>
-            </a:xfrm>
-            <a:prstGeom prst="straightConnector1">
-              <a:avLst/>
-            </a:prstGeom>
-            <a:ln w="57150">
-              <a:headEnd type="none" w="med" len="med"/>
-              <a:tailEnd type="stealth" w="med" len="med"/>
-            </a:ln>
-          </p:spPr>
-          <p:style>
-            <a:lnRef idx="2">
-              <a:schemeClr val="dk1"/>
-            </a:lnRef>
-            <a:fillRef idx="0">
-              <a:schemeClr val="dk1"/>
-            </a:fillRef>
-            <a:effectRef idx="1">
-              <a:schemeClr val="dk1"/>
-            </a:effectRef>
-            <a:fontRef idx="minor">
-              <a:schemeClr val="tx1"/>
-            </a:fontRef>
-          </p:style>
-        </p:cxnSp>
-        <p:sp>
-          <p:nvSpPr>
-            <p:cNvPr id="113" name="Arc 112">
-              <a:extLst>
-                <a:ext uri="{FF2B5EF4-FFF2-40B4-BE49-F238E27FC236}">
-                  <a16:creationId xmlns:a16="http://schemas.microsoft.com/office/drawing/2014/main" id="{AC4DE1E2-7934-962D-94FE-81C05D9A2CB7}"/>
-                </a:ext>
-              </a:extLst>
-            </p:cNvPr>
-            <p:cNvSpPr/>
-            <p:nvPr/>
-          </p:nvSpPr>
-          <p:spPr>
-            <a:xfrm rot="18928753">
-              <a:off x="546233" y="1058001"/>
-              <a:ext cx="3154963" cy="3154963"/>
-            </a:xfrm>
-            <a:prstGeom prst="arc">
-              <a:avLst>
-                <a:gd name="adj1" fmla="val 17041549"/>
-                <a:gd name="adj2" fmla="val 20776843"/>
-              </a:avLst>
-            </a:prstGeom>
-            <a:ln w="57150">
-              <a:headEnd type="none" w="med" len="med"/>
-              <a:tailEnd type="stealth" w="med" len="med"/>
-            </a:ln>
-          </p:spPr>
-          <p:style>
-            <a:lnRef idx="2">
-              <a:schemeClr val="dk1"/>
-            </a:lnRef>
-            <a:fillRef idx="0">
-              <a:schemeClr val="dk1"/>
-            </a:fillRef>
-            <a:effectRef idx="1">
-              <a:schemeClr val="dk1"/>
-            </a:effectRef>
-            <a:fontRef idx="minor">
-              <a:schemeClr val="tx1"/>
-            </a:fontRef>
-          </p:style>
-          <p:txBody>
-            <a:bodyPr rtlCol="0" anchor="ctr"/>
-            <a:lstStyle/>
-            <a:p>
-              <a:pPr algn="ctr"/>
-              <a:endParaRPr lang="en-US"/>
-            </a:p>
-          </p:txBody>
-        </p:sp>
-      </p:grpSp>
-      <p:grpSp>
-        <p:nvGrpSpPr>
-          <p:cNvPr id="115" name="Group 114">
-            <a:extLst>
-              <a:ext uri="{FF2B5EF4-FFF2-40B4-BE49-F238E27FC236}">
-                <a16:creationId xmlns:a16="http://schemas.microsoft.com/office/drawing/2014/main" id="{2D007ADC-E5C3-B6E1-EF74-11BF83ACB8A1}"/>
-              </a:ext>
-            </a:extLst>
-          </p:cNvPr>
-          <p:cNvGrpSpPr/>
-          <p:nvPr/>
-        </p:nvGrpSpPr>
-        <p:grpSpPr>
-          <a:xfrm>
-            <a:off x="8328248" y="1916832"/>
-            <a:ext cx="3166809" cy="5171187"/>
-            <a:chOff x="546233" y="-958223"/>
-            <a:chExt cx="3166809" cy="5171187"/>
-          </a:xfrm>
-        </p:grpSpPr>
-        <p:sp>
-          <p:nvSpPr>
-            <p:cNvPr id="116" name="Oval 115">
-              <a:extLst>
-                <a:ext uri="{FF2B5EF4-FFF2-40B4-BE49-F238E27FC236}">
-                  <a16:creationId xmlns:a16="http://schemas.microsoft.com/office/drawing/2014/main" id="{DBF51847-6C4F-4CD2-0D56-1F00FA179591}"/>
-                </a:ext>
-              </a:extLst>
-            </p:cNvPr>
-            <p:cNvSpPr/>
-            <p:nvPr/>
-          </p:nvSpPr>
-          <p:spPr>
-            <a:xfrm>
-              <a:off x="695400" y="1268760"/>
-              <a:ext cx="720080" cy="720080"/>
-            </a:xfrm>
-            <a:prstGeom prst="ellipse">
-              <a:avLst/>
-            </a:prstGeom>
-            <a:solidFill>
-              <a:srgbClr val="FBE4CC"/>
-            </a:solidFill>
-          </p:spPr>
-          <p:style>
-            <a:lnRef idx="2">
-              <a:schemeClr val="accent1">
-                <a:shade val="15000"/>
-              </a:schemeClr>
-            </a:lnRef>
-            <a:fillRef idx="1">
-              <a:schemeClr val="accent1"/>
-            </a:fillRef>
-            <a:effectRef idx="0">
-              <a:schemeClr val="accent1"/>
-            </a:effectRef>
-            <a:fontRef idx="minor">
-              <a:schemeClr val="lt1"/>
-            </a:fontRef>
-          </p:style>
-          <p:txBody>
-            <a:bodyPr rtlCol="0" anchor="ctr"/>
-            <a:lstStyle/>
-            <a:p>
-              <a:pPr algn="ctr"/>
-              <a:endParaRPr lang="en-US" sz="750" dirty="0">
-                <a:latin typeface="Helvetica" pitchFamily="2" charset="0"/>
-              </a:endParaRPr>
-            </a:p>
-          </p:txBody>
-        </p:sp>
-        <p:sp>
-          <p:nvSpPr>
-            <p:cNvPr id="117" name="Oval 116">
-              <a:extLst>
-                <a:ext uri="{FF2B5EF4-FFF2-40B4-BE49-F238E27FC236}">
-                  <a16:creationId xmlns:a16="http://schemas.microsoft.com/office/drawing/2014/main" id="{DD989324-DA39-8E6B-81E4-B390660F540B}"/>
-                </a:ext>
-              </a:extLst>
-            </p:cNvPr>
-            <p:cNvSpPr/>
-            <p:nvPr/>
-          </p:nvSpPr>
-          <p:spPr>
-            <a:xfrm>
-              <a:off x="1775520" y="1268760"/>
-              <a:ext cx="720080" cy="720080"/>
-            </a:xfrm>
-            <a:prstGeom prst="ellipse">
-              <a:avLst/>
-            </a:prstGeom>
-            <a:solidFill>
-              <a:srgbClr val="FCAD6B"/>
-            </a:solidFill>
-          </p:spPr>
-          <p:style>
-            <a:lnRef idx="2">
-              <a:schemeClr val="accent1">
-                <a:shade val="15000"/>
-              </a:schemeClr>
-            </a:lnRef>
-            <a:fillRef idx="1">
-              <a:schemeClr val="accent1"/>
-            </a:fillRef>
-            <a:effectRef idx="0">
-              <a:schemeClr val="accent1"/>
-            </a:effectRef>
-            <a:fontRef idx="minor">
-              <a:schemeClr val="lt1"/>
-            </a:fontRef>
-          </p:style>
-          <p:txBody>
-            <a:bodyPr rtlCol="0" anchor="ctr"/>
-            <a:lstStyle/>
-            <a:p>
-              <a:pPr algn="ctr"/>
-              <a:endParaRPr lang="en-US" sz="750" dirty="0">
-                <a:latin typeface="Helvetica" pitchFamily="2" charset="0"/>
-              </a:endParaRPr>
-            </a:p>
-          </p:txBody>
-        </p:sp>
-        <p:sp>
-          <p:nvSpPr>
-            <p:cNvPr id="118" name="Oval 117">
-              <a:extLst>
-                <a:ext uri="{FF2B5EF4-FFF2-40B4-BE49-F238E27FC236}">
-                  <a16:creationId xmlns:a16="http://schemas.microsoft.com/office/drawing/2014/main" id="{55A78567-F276-A8FC-8124-0008018D3B37}"/>
-                </a:ext>
-              </a:extLst>
-            </p:cNvPr>
-            <p:cNvSpPr/>
-            <p:nvPr/>
-          </p:nvSpPr>
-          <p:spPr>
-            <a:xfrm>
-              <a:off x="2855640" y="1268760"/>
-              <a:ext cx="720080" cy="720080"/>
-            </a:xfrm>
-            <a:prstGeom prst="ellipse">
-              <a:avLst/>
-            </a:prstGeom>
-            <a:solidFill>
-              <a:srgbClr val="E6550E"/>
-            </a:solidFill>
-          </p:spPr>
-          <p:style>
-            <a:lnRef idx="2">
-              <a:schemeClr val="accent1">
-                <a:shade val="15000"/>
-              </a:schemeClr>
-            </a:lnRef>
-            <a:fillRef idx="1">
-              <a:schemeClr val="accent1"/>
-            </a:fillRef>
-            <a:effectRef idx="0">
-              <a:schemeClr val="accent1"/>
-            </a:effectRef>
-            <a:fontRef idx="minor">
-              <a:schemeClr val="lt1"/>
-            </a:fontRef>
-          </p:style>
-          <p:txBody>
-            <a:bodyPr rtlCol="0" anchor="ctr"/>
-            <a:lstStyle/>
-            <a:p>
-              <a:pPr algn="ctr"/>
-              <a:endParaRPr lang="en-US" sz="750" dirty="0">
-                <a:latin typeface="Helvetica" pitchFamily="2" charset="0"/>
-              </a:endParaRPr>
-            </a:p>
-          </p:txBody>
-        </p:sp>
-        <p:cxnSp>
-          <p:nvCxnSpPr>
-            <p:cNvPr id="119" name="Straight Arrow Connector 118">
-              <a:extLst>
-                <a:ext uri="{FF2B5EF4-FFF2-40B4-BE49-F238E27FC236}">
-                  <a16:creationId xmlns:a16="http://schemas.microsoft.com/office/drawing/2014/main" id="{9BFE702E-61CF-FC17-0D22-ADA97846BBE6}"/>
-                </a:ext>
-              </a:extLst>
-            </p:cNvPr>
-            <p:cNvCxnSpPr>
-              <a:cxnSpLocks/>
-            </p:cNvCxnSpPr>
-            <p:nvPr/>
-          </p:nvCxnSpPr>
-          <p:spPr>
-            <a:xfrm>
-              <a:off x="1432100" y="1484784"/>
-              <a:ext cx="343420" cy="0"/>
-            </a:xfrm>
-            <a:prstGeom prst="straightConnector1">
-              <a:avLst/>
-            </a:prstGeom>
-            <a:ln w="57150">
-              <a:headEnd type="none" w="med" len="med"/>
-              <a:tailEnd type="stealth" w="med" len="med"/>
-            </a:ln>
-          </p:spPr>
-          <p:style>
-            <a:lnRef idx="2">
-              <a:schemeClr val="dk1"/>
-            </a:lnRef>
-            <a:fillRef idx="0">
-              <a:schemeClr val="dk1"/>
-            </a:fillRef>
-            <a:effectRef idx="1">
-              <a:schemeClr val="dk1"/>
-            </a:effectRef>
-            <a:fontRef idx="minor">
-              <a:schemeClr val="tx1"/>
-            </a:fontRef>
-          </p:style>
-        </p:cxnSp>
-        <p:cxnSp>
-          <p:nvCxnSpPr>
-            <p:cNvPr id="121" name="Straight Arrow Connector 120">
-              <a:extLst>
-                <a:ext uri="{FF2B5EF4-FFF2-40B4-BE49-F238E27FC236}">
-                  <a16:creationId xmlns:a16="http://schemas.microsoft.com/office/drawing/2014/main" id="{AD3BFCF8-408C-BD12-DD7B-C00AAECD81C5}"/>
-                </a:ext>
-              </a:extLst>
-            </p:cNvPr>
-            <p:cNvCxnSpPr>
-              <a:cxnSpLocks/>
-            </p:cNvCxnSpPr>
-            <p:nvPr/>
-          </p:nvCxnSpPr>
-          <p:spPr>
-            <a:xfrm flipH="1">
-              <a:off x="1415480" y="1772816"/>
-              <a:ext cx="343420" cy="0"/>
-            </a:xfrm>
-            <a:prstGeom prst="straightConnector1">
-              <a:avLst/>
-            </a:prstGeom>
-            <a:ln w="57150">
-              <a:headEnd type="none" w="med" len="med"/>
-              <a:tailEnd type="stealth" w="med" len="med"/>
-            </a:ln>
-          </p:spPr>
-          <p:style>
-            <a:lnRef idx="2">
-              <a:schemeClr val="dk1"/>
-            </a:lnRef>
-            <a:fillRef idx="0">
-              <a:schemeClr val="dk1"/>
-            </a:fillRef>
-            <a:effectRef idx="1">
-              <a:schemeClr val="dk1"/>
-            </a:effectRef>
-            <a:fontRef idx="minor">
-              <a:schemeClr val="tx1"/>
-            </a:fontRef>
-          </p:style>
-        </p:cxnSp>
-        <p:sp>
-          <p:nvSpPr>
-            <p:cNvPr id="123" name="Arc 122">
-              <a:extLst>
-                <a:ext uri="{FF2B5EF4-FFF2-40B4-BE49-F238E27FC236}">
-                  <a16:creationId xmlns:a16="http://schemas.microsoft.com/office/drawing/2014/main" id="{095AF2C9-51C7-12D1-8BBE-EA77AD84C585}"/>
-                </a:ext>
-              </a:extLst>
-            </p:cNvPr>
-            <p:cNvSpPr/>
-            <p:nvPr/>
-          </p:nvSpPr>
-          <p:spPr>
-            <a:xfrm rot="18928753">
-              <a:off x="546233" y="1058001"/>
-              <a:ext cx="3154963" cy="3154963"/>
-            </a:xfrm>
-            <a:prstGeom prst="arc">
-              <a:avLst>
-                <a:gd name="adj1" fmla="val 17041549"/>
-                <a:gd name="adj2" fmla="val 20776843"/>
-              </a:avLst>
-            </a:prstGeom>
-            <a:ln w="57150">
-              <a:headEnd type="none" w="med" len="med"/>
-              <a:tailEnd type="stealth" w="med" len="med"/>
-            </a:ln>
-          </p:spPr>
-          <p:style>
-            <a:lnRef idx="2">
-              <a:schemeClr val="dk1"/>
-            </a:lnRef>
-            <a:fillRef idx="0">
-              <a:schemeClr val="dk1"/>
-            </a:fillRef>
-            <a:effectRef idx="1">
-              <a:schemeClr val="dk1"/>
-            </a:effectRef>
-            <a:fontRef idx="minor">
-              <a:schemeClr val="tx1"/>
-            </a:fontRef>
-          </p:style>
-          <p:txBody>
-            <a:bodyPr rtlCol="0" anchor="ctr"/>
-            <a:lstStyle/>
-            <a:p>
-              <a:pPr algn="ctr"/>
-              <a:endParaRPr lang="en-US"/>
-            </a:p>
-          </p:txBody>
-        </p:sp>
-        <p:sp>
-          <p:nvSpPr>
-            <p:cNvPr id="124" name="Arc 123">
-              <a:extLst>
-                <a:ext uri="{FF2B5EF4-FFF2-40B4-BE49-F238E27FC236}">
-                  <a16:creationId xmlns:a16="http://schemas.microsoft.com/office/drawing/2014/main" id="{0E668D11-7D4D-DB10-EC91-BEDE70BFA7DE}"/>
-                </a:ext>
-              </a:extLst>
-            </p:cNvPr>
-            <p:cNvSpPr/>
-            <p:nvPr/>
-          </p:nvSpPr>
-          <p:spPr>
-            <a:xfrm rot="18928753" flipH="1" flipV="1">
-              <a:off x="558079" y="-958223"/>
-              <a:ext cx="3154963" cy="3154963"/>
-            </a:xfrm>
-            <a:prstGeom prst="arc">
-              <a:avLst>
-                <a:gd name="adj1" fmla="val 17041549"/>
-                <a:gd name="adj2" fmla="val 20776843"/>
-              </a:avLst>
-            </a:prstGeom>
-            <a:ln w="57150">
-              <a:headEnd type="none" w="med" len="med"/>
-              <a:tailEnd type="stealth" w="med" len="med"/>
-            </a:ln>
-          </p:spPr>
-          <p:style>
-            <a:lnRef idx="2">
-              <a:schemeClr val="dk1"/>
-            </a:lnRef>
-            <a:fillRef idx="0">
-              <a:schemeClr val="dk1"/>
-            </a:fillRef>
-            <a:effectRef idx="1">
-              <a:schemeClr val="dk1"/>
-            </a:effectRef>
-            <a:fontRef idx="minor">
-              <a:schemeClr val="tx1"/>
-            </a:fontRef>
-          </p:style>
-          <p:txBody>
-            <a:bodyPr rtlCol="0" anchor="ctr"/>
-            <a:lstStyle/>
-            <a:p>
-              <a:pPr algn="ctr"/>
-              <a:endParaRPr lang="en-US"/>
-            </a:p>
-          </p:txBody>
-        </p:sp>
-      </p:grpSp>
       <p:sp>
         <p:nvSpPr>
           <p:cNvPr id="125" name="TextBox 124">
@@ -5436,7 +4435,7 @@
         </p:nvSpPr>
         <p:spPr>
           <a:xfrm>
-            <a:off x="1800684" y="548680"/>
+            <a:off x="1932647" y="440408"/>
             <a:ext cx="639919" cy="430887"/>
           </a:xfrm>
           <a:prstGeom prst="rect">
@@ -5473,7 +4472,7 @@
         </p:nvSpPr>
         <p:spPr>
           <a:xfrm>
-            <a:off x="5264810" y="548680"/>
+            <a:off x="5396771" y="440408"/>
             <a:ext cx="1518364" cy="430887"/>
           </a:xfrm>
           <a:prstGeom prst="rect">
@@ -5510,7 +4509,7 @@
         </p:nvSpPr>
         <p:spPr>
           <a:xfrm>
-            <a:off x="9209967" y="548680"/>
+            <a:off x="1569475" y="2745826"/>
             <a:ext cx="1298753" cy="430887"/>
           </a:xfrm>
           <a:prstGeom prst="rect">
@@ -5547,7 +4546,7 @@
         </p:nvSpPr>
         <p:spPr>
           <a:xfrm>
-            <a:off x="849091" y="3091607"/>
+            <a:off x="5003827" y="2745826"/>
             <a:ext cx="2366353" cy="430887"/>
           </a:xfrm>
           <a:prstGeom prst="rect">
@@ -5566,81 +4565,6 @@
                 <a:latin typeface="Helvetica" pitchFamily="2" charset="0"/>
               </a:rPr>
               <a:t>Relaxed unilinear</a:t>
-            </a:r>
-          </a:p>
-        </p:txBody>
-      </p:sp>
-      <p:sp>
-        <p:nvSpPr>
-          <p:cNvPr id="130" name="TextBox 129">
-            <a:extLst>
-              <a:ext uri="{FF2B5EF4-FFF2-40B4-BE49-F238E27FC236}">
-                <a16:creationId xmlns:a16="http://schemas.microsoft.com/office/drawing/2014/main" id="{7C7D40AB-4A9A-952F-7749-BA64CD8993D3}"/>
-              </a:ext>
-            </a:extLst>
-          </p:cNvPr>
-          <p:cNvSpPr txBox="1"/>
-          <p:nvPr/>
-        </p:nvSpPr>
-        <p:spPr>
-          <a:xfrm>
-            <a:off x="4534642" y="3091607"/>
-            <a:ext cx="2978701" cy="430887"/>
-          </a:xfrm>
-          <a:prstGeom prst="rect">
-            <a:avLst/>
-          </a:prstGeom>
-          <a:noFill/>
-        </p:spPr>
-        <p:txBody>
-          <a:bodyPr wrap="none" rtlCol="0">
-            <a:spAutoFit/>
-          </a:bodyPr>
-          <a:lstStyle/>
-          <a:p>
-            <a:r>
-              <a:rPr lang="en-US" sz="2200" dirty="0">
-                <a:latin typeface="Helvetica" pitchFamily="2" charset="0"/>
-              </a:rPr>
-              <a:t>Alternative trajectories</a:t>
-            </a:r>
-          </a:p>
-        </p:txBody>
-      </p:sp>
-      <p:sp>
-        <p:nvSpPr>
-          <p:cNvPr id="131" name="TextBox 130">
-            <a:extLst>
-              <a:ext uri="{FF2B5EF4-FFF2-40B4-BE49-F238E27FC236}">
-                <a16:creationId xmlns:a16="http://schemas.microsoft.com/office/drawing/2014/main" id="{A417A167-260C-934C-49E1-CE0A94802303}"/>
-              </a:ext>
-            </a:extLst>
-          </p:cNvPr>
-          <p:cNvSpPr txBox="1"/>
-          <p:nvPr/>
-        </p:nvSpPr>
-        <p:spPr>
-          <a:xfrm>
-            <a:off x="8239769" y="3091607"/>
-            <a:ext cx="3341486" cy="769441"/>
-          </a:xfrm>
-          <a:prstGeom prst="rect">
-            <a:avLst/>
-          </a:prstGeom>
-          <a:noFill/>
-        </p:spPr>
-        <p:txBody>
-          <a:bodyPr wrap="square" rtlCol="0">
-            <a:spAutoFit/>
-          </a:bodyPr>
-          <a:lstStyle/>
-          <a:p>
-            <a:pPr algn="ctr"/>
-            <a:r>
-              <a:rPr lang="en-US" sz="2200" dirty="0">
-                <a:latin typeface="Helvetica" pitchFamily="2" charset="0"/>
-              </a:rPr>
-              <a:t>Alternative trajectories (reversible)</a:t>
             </a:r>
           </a:p>
         </p:txBody>
@@ -5659,7 +4583,7 @@
         </p:nvSpPr>
         <p:spPr>
           <a:xfrm>
-            <a:off x="2320751" y="6058421"/>
+            <a:off x="724520" y="5264943"/>
             <a:ext cx="360000" cy="360000"/>
           </a:xfrm>
           <a:prstGeom prst="rect">
@@ -5711,7 +4635,7 @@
         </p:nvSpPr>
         <p:spPr>
           <a:xfrm>
-            <a:off x="2680751" y="6073867"/>
+            <a:off x="1084520" y="5280389"/>
             <a:ext cx="2281394" cy="338554"/>
           </a:xfrm>
           <a:prstGeom prst="rect">
@@ -5748,7 +4672,7 @@
         </p:nvSpPr>
         <p:spPr>
           <a:xfrm>
-            <a:off x="5264759" y="6058421"/>
+            <a:off x="3668528" y="5264943"/>
             <a:ext cx="360000" cy="360000"/>
           </a:xfrm>
           <a:prstGeom prst="rect">
@@ -5800,7 +4724,7 @@
         </p:nvSpPr>
         <p:spPr>
           <a:xfrm>
-            <a:off x="5624759" y="6073867"/>
+            <a:off x="4028528" y="5280389"/>
             <a:ext cx="1889876" cy="338554"/>
           </a:xfrm>
           <a:prstGeom prst="rect">
@@ -5837,7 +4761,7 @@
         </p:nvSpPr>
         <p:spPr>
           <a:xfrm>
-            <a:off x="8011845" y="6058421"/>
+            <a:off x="6415614" y="5264943"/>
             <a:ext cx="360000" cy="360000"/>
           </a:xfrm>
           <a:prstGeom prst="rect">
@@ -5889,7 +4813,7 @@
         </p:nvSpPr>
         <p:spPr>
           <a:xfrm>
-            <a:off x="8371845" y="6073867"/>
+            <a:off x="6775614" y="5280389"/>
             <a:ext cx="1313180" cy="338554"/>
           </a:xfrm>
           <a:prstGeom prst="rect">
@@ -5928,7 +4852,7 @@
 <file path=ppt/theme/theme1.xml><?xml version="1.0" encoding="utf-8"?>
 <a:theme xmlns:a="http://schemas.openxmlformats.org/drawingml/2006/main" name="Office Theme">
   <a:themeElements>
-    <a:clrScheme name="Office">
+    <a:clrScheme name="Office Theme">
       <a:dk1>
         <a:sysClr val="windowText" lastClr="000000"/>
       </a:dk1>
@@ -5966,7 +4890,7 @@
         <a:srgbClr val="96607D"/>
       </a:folHlink>
     </a:clrScheme>
-    <a:fontScheme name="Office">
+    <a:fontScheme name="Office Theme">
       <a:majorFont>
         <a:latin typeface="Aptos Display" panose="02110004020202020204"/>
         <a:ea typeface=""/>
@@ -6072,7 +4996,7 @@
         <a:font script="Tfng" typeface="Ebrima"/>
       </a:minorFont>
     </a:fontScheme>
-    <a:fmtScheme name="Office">
+    <a:fmtScheme name="Office Theme">
       <a:fillStyleLst>
         <a:solidFill>
           <a:schemeClr val="phClr"/>

</xml_diff>